<commit_message>
Docs and pitch filled with measured numbers; runbook verified-versus-unrun table
</commit_message>
<xml_diff>
--- a/docs/pitch/Beetle-pitch.pptx
+++ b/docs/pitch/Beetle-pitch.pptx
@@ -112,7 +112,7 @@
   <p:extLst>
     <p:ext uri="{521415D9-36F7-43E2-AB2F-B90AF26B5E84}">
       <p14:sectionLst xmlns:p14="http://schemas.microsoft.com/office/powerpoint/2010/main">
-        <p14:section name="Beetle pitch" id="{298fa67b-bd4d-4905-6626-094fe9ffba75}">
+        <p14:section name="Beetle pitch" id="{619f5f1b-d9ed-eeea-12a4-72fc5db922cd}">
           <p14:sldIdLst>
             <p14:sldId id="256"/>
             <p14:sldId id="257"/>
@@ -702,7 +702,7 @@
           <a:p>
             <a:r>
               <a:rPr lang="en-US" dirty="0"/>
-              <a:t>Play the recording here. Captions follow the storyboard; shots that cannot be produced honestly are cut, not faked.</a:t>
+              <a:t>Play the recording here. Captions follow docs/STORYBOARD.md; the mode caption is set to whichever agent mode was green at recording time. Rehearsal timings: brief 14 s on a quiet GPU, edits 2 to 14 s, DISCONNECTED_GOAL refused and repaired in 3.0 s. Shots that cannot be produced honestly are cut, not faked.</a:t>
             </a:r>
             <a:endParaRPr lang="en-US" dirty="0"/>
           </a:p>
@@ -878,7 +878,7 @@
           <a:p>
             <a:r>
               <a:rPr lang="en-US" dirty="0"/>
-              <a:t>Read the measured numbers from the filled cards. If a card is still bracketed, say that the measurement is pending rather than guessing.</a:t>
+              <a:t>Read the cards. Say out loud: the 10 s brief target is not met; a valid brief takes 24 to 28 s warm on a quiet GPU and 14 s was seen once after normalization. Edits commit in 2 to 14 s. Session continuity and the offline proof are covered by tests or procedure but not yet measured live; say so rather than guessing. The 27b was never benchmarked.</a:t>
             </a:r>
             <a:endParaRPr lang="en-US" dirty="0"/>
           </a:p>
@@ -4400,7 +4400,7 @@
                   <a:schemeClr val="tx2"/>
                 </a:solidFill>
               </a:rPr>
-              <a:t>90 to 120 second demo recording, dropped in after rehearsal</a:t>
+              <a:t>Insert the rehearsal recording here (90 to 120 s). Not yet recorded at 13:40 CDT.</a:t>
             </a:r>
             <a:endParaRPr lang="en-US" sz="1400" dirty="0"/>
           </a:p>
@@ -4414,7 +4414,7 @@
                   <a:schemeClr val="tx2"/>
                 </a:solidFill>
               </a:rPr>
-              <a:t>Any time compression is labelled on screen</a:t>
+              <a:t>The caption names the agent mode used; any time compression is labelled on screen</a:t>
             </a:r>
             <a:endParaRPr lang="en-US" sz="1400" dirty="0"/>
           </a:p>
@@ -4648,7 +4648,7 @@
                   <a:schemeClr val="tx1"/>
                 </a:solidFill>
               </a:rPr>
-              <a:t>The validator refuses a world nobody can finish. The agent repairs it and commits only a passing version.</a:t>
+              <a:t>The validator refuses a world nobody can finish (DISCONNECTED_GOAL). The agent repairs it and commits only a passing version.</a:t>
             </a:r>
             <a:endParaRPr lang="en-US" sz="1000" dirty="0"/>
           </a:p>
@@ -4676,7 +4676,7 @@
                   <a:schemeClr val="tx1"/>
                 </a:solidFill>
               </a:rPr>
-              <a:t>Measured on one GB10. Local model, local agent, no cloud.</a:t>
+              <a:t>Measured on one GB10. Local model, local agent in [direct or OpenClaw] mode, no cloud.</a:t>
             </a:r>
             <a:endParaRPr lang="en-US" sz="1000" dirty="0"/>
           </a:p>
@@ -5802,7 +5802,7 @@
                   <a:schemeClr val="accent1"/>
                 </a:solidFill>
               </a:rPr>
-              <a:t>validation issues go back for repair, at most [max attempts] attempts, then the request fails honestly</a:t>
+              <a:t>validation issues go back for repair, at most 2 attempts, then the request fails honestly</a:t>
             </a:r>
             <a:endParaRPr lang="en-US" sz="900" dirty="0"/>
           </a:p>
@@ -6495,12 +6495,12 @@
         </p:nvSpPr>
         <p:spPr>
           <a:xfrm>
-            <a:off x="457200" y="1188720"/>
-            <a:ext cx="2651760" cy="1325880"/>
+            <a:off x="457200" y="1115568"/>
+            <a:ext cx="2651760" cy="987552"/>
           </a:xfrm>
           <a:prstGeom prst="roundRect">
             <a:avLst>
-              <a:gd name="adj" fmla="val 5517"/>
+              <a:gd name="adj" fmla="val 7407"/>
             </a:avLst>
           </a:prstGeom>
           <a:solidFill>
@@ -6522,8 +6522,8 @@
         </p:nvSpPr>
         <p:spPr>
           <a:xfrm>
-            <a:off x="621792" y="1316736"/>
-            <a:ext cx="2322576" cy="228600"/>
+            <a:off x="603504" y="1188720"/>
+            <a:ext cx="2359152" cy="182880"/>
           </a:xfrm>
           <a:prstGeom prst="rect">
             <a:avLst/>
@@ -6539,14 +6539,14 @@
               <a:buNone/>
             </a:pPr>
             <a:r>
-              <a:rPr lang="en-US" sz="1000" b="1" spc="200" kern="0" dirty="0">
+              <a:rPr lang="en-US" sz="900" b="1" spc="200" kern="0" dirty="0">
                 <a:solidFill>
                   <a:schemeClr val="accent1"/>
                 </a:solidFill>
               </a:rPr>
               <a:t>MODEL</a:t>
             </a:r>
-            <a:endParaRPr lang="en-US" sz="1000" dirty="0"/>
+            <a:endParaRPr lang="en-US" sz="900" dirty="0"/>
           </a:p>
         </p:txBody>
       </p:sp>
@@ -6558,8 +6558,8 @@
         </p:nvSpPr>
         <p:spPr>
           <a:xfrm>
-            <a:off x="621792" y="1572768"/>
-            <a:ext cx="2322576" cy="548640"/>
+            <a:off x="603504" y="1362456"/>
+            <a:ext cx="2359152" cy="274320"/>
           </a:xfrm>
           <a:prstGeom prst="rect">
             <a:avLst/>
@@ -6575,14 +6575,14 @@
               <a:buNone/>
             </a:pPr>
             <a:r>
-              <a:rPr lang="en-US" sz="1500" b="1" dirty="0">
+              <a:rPr lang="en-US" sz="1250" b="1" dirty="0">
                 <a:solidFill>
                   <a:schemeClr val="accent1"/>
                 </a:solidFill>
               </a:rPr>
-              <a:t>[model tag], [quantization]</a:t>
-            </a:r>
-            <a:endParaRPr lang="en-US" sz="1500" dirty="0"/>
+              <a:t>qwen3.5:4b, Q4_K_M</a:t>
+            </a:r>
+            <a:endParaRPr lang="en-US" sz="1250" dirty="0"/>
           </a:p>
         </p:txBody>
       </p:sp>
@@ -6594,8 +6594,8 @@
         </p:nvSpPr>
         <p:spPr>
           <a:xfrm>
-            <a:off x="621792" y="2157984"/>
-            <a:ext cx="2322576" cy="347472"/>
+            <a:off x="603504" y="1645920"/>
+            <a:ext cx="2359152" cy="438912"/>
           </a:xfrm>
           <a:prstGeom prst="rect">
             <a:avLst/>
@@ -6611,31 +6611,31 @@
               <a:buNone/>
             </a:pPr>
             <a:r>
-              <a:rPr lang="en-US" sz="1000" dirty="0">
+              <a:rPr lang="en-US" sz="750" dirty="0">
                 <a:solidFill>
                   <a:schemeClr val="tx2"/>
                 </a:solidFill>
               </a:rPr>
-              <a:t>on the GB10 via Ollama on loopback</a:t>
-            </a:r>
-            <a:endParaRPr lang="en-US" sz="1000" dirty="0"/>
-          </a:p>
-        </p:txBody>
-      </p:sp>
-      <p:sp>
-        <p:nvSpPr>
-          <p:cNvPr id="19" name="result card BRIEF TO PLAYABLE"/>
-          <p:cNvSpPr/>
-          <p:nvPr/>
-        </p:nvSpPr>
-        <p:spPr>
-          <a:xfrm>
-            <a:off x="3246120" y="1188720"/>
-            <a:ext cx="2651760" cy="1325880"/>
+              <a:t>4.7B, 3.4 GB, Ollama 0.35.1 on loopback. qwen3.8:27b not benchmarked: pull failed once, re-downloading. docs/MODEL_SELECTION.md</a:t>
+            </a:r>
+            <a:endParaRPr lang="en-US" sz="750" dirty="0"/>
+          </a:p>
+        </p:txBody>
+      </p:sp>
+      <p:sp>
+        <p:nvSpPr>
+          <p:cNvPr id="19" name="result card BRIEF, WARM, QUIET GPU"/>
+          <p:cNvSpPr/>
+          <p:nvPr/>
+        </p:nvSpPr>
+        <p:spPr>
+          <a:xfrm>
+            <a:off x="3246120" y="1115568"/>
+            <a:ext cx="2651760" cy="987552"/>
           </a:xfrm>
           <a:prstGeom prst="roundRect">
             <a:avLst>
-              <a:gd name="adj" fmla="val 5517"/>
+              <a:gd name="adj" fmla="val 7407"/>
             </a:avLst>
           </a:prstGeom>
           <a:solidFill>
@@ -6651,14 +6651,14 @@
       </p:sp>
       <p:sp>
         <p:nvSpPr>
-          <p:cNvPr id="20" name="label BRIEF TO PLAYABLE"/>
+          <p:cNvPr id="20" name="label BRIEF, WARM, QUIET GPU"/>
           <p:cNvSpPr txBox="1"/>
           <p:nvPr/>
         </p:nvSpPr>
         <p:spPr>
           <a:xfrm>
-            <a:off x="3410712" y="1316736"/>
-            <a:ext cx="2322576" cy="228600"/>
+            <a:off x="3392424" y="1188720"/>
+            <a:ext cx="2359152" cy="182880"/>
           </a:xfrm>
           <a:prstGeom prst="rect">
             <a:avLst/>
@@ -6674,27 +6674,27 @@
               <a:buNone/>
             </a:pPr>
             <a:r>
-              <a:rPr lang="en-US" sz="1000" b="1" spc="200" kern="0" dirty="0">
+              <a:rPr lang="en-US" sz="900" b="1" spc="200" kern="0" dirty="0">
                 <a:solidFill>
                   <a:schemeClr val="accent1"/>
                 </a:solidFill>
               </a:rPr>
-              <a:t>BRIEF TO PLAYABLE</a:t>
-            </a:r>
-            <a:endParaRPr lang="en-US" sz="1000" dirty="0"/>
-          </a:p>
-        </p:txBody>
-      </p:sp>
-      <p:sp>
-        <p:nvSpPr>
-          <p:cNvPr id="21" name="result value BRIEF TO PLAYABLE"/>
+              <a:t>BRIEF, WARM, QUIET GPU</a:t>
+            </a:r>
+            <a:endParaRPr lang="en-US" sz="900" dirty="0"/>
+          </a:p>
+        </p:txBody>
+      </p:sp>
+      <p:sp>
+        <p:nvSpPr>
+          <p:cNvPr id="21" name="result value BRIEF, WARM, QUIET GPU"/>
           <p:cNvSpPr txBox="1"/>
           <p:nvPr/>
         </p:nvSpPr>
         <p:spPr>
           <a:xfrm>
-            <a:off x="3410712" y="1572768"/>
-            <a:ext cx="2322576" cy="548640"/>
+            <a:off x="3392424" y="1362456"/>
+            <a:ext cx="2359152" cy="274320"/>
           </a:xfrm>
           <a:prstGeom prst="rect">
             <a:avLst/>
@@ -6710,27 +6710,27 @@
               <a:buNone/>
             </a:pPr>
             <a:r>
-              <a:rPr lang="en-US" sz="1500" b="1" dirty="0">
+              <a:rPr lang="en-US" sz="1250" b="1" dirty="0">
                 <a:solidFill>
                   <a:schemeClr val="accent1"/>
                 </a:solidFill>
               </a:rPr>
-              <a:t>[min] / [p50] / [max] s</a:t>
-            </a:r>
-            <a:endParaRPr lang="en-US" sz="1500" dirty="0"/>
-          </a:p>
-        </p:txBody>
-      </p:sp>
-      <p:sp>
-        <p:nvSpPr>
-          <p:cNvPr id="22" name="result sub BRIEF TO PLAYABLE"/>
+              <a:t>26.2 / 26.5 / 27.7 s</a:t>
+            </a:r>
+            <a:endParaRPr lang="en-US" sz="1250" dirty="0"/>
+          </a:p>
+        </p:txBody>
+      </p:sp>
+      <p:sp>
+        <p:nvSpPr>
+          <p:cNvPr id="22" name="result sub BRIEF, WARM, QUIET GPU"/>
           <p:cNvSpPr txBox="1"/>
           <p:nvPr/>
         </p:nvSpPr>
         <p:spPr>
           <a:xfrm>
-            <a:off x="3410712" y="2157984"/>
-            <a:ext cx="2322576" cy="347472"/>
+            <a:off x="3392424" y="1645920"/>
+            <a:ext cx="2359152" cy="438912"/>
           </a:xfrm>
           <a:prstGeom prst="rect">
             <a:avLst/>
@@ -6746,31 +6746,31 @@
               <a:buNone/>
             </a:pPr>
             <a:r>
-              <a:rPr lang="en-US" sz="1000" dirty="0">
+              <a:rPr lang="en-US" sz="750" dirty="0">
                 <a:solidFill>
                   <a:schemeClr val="tx2"/>
                 </a:solidFill>
               </a:rPr>
-              <a:t>over [N] runs, cold load [cold s] reported separately</a:t>
-            </a:r>
-            <a:endParaRPr lang="en-US" sz="1000" dirty="0"/>
-          </a:p>
-        </p:txBody>
-      </p:sp>
-      <p:sp>
-        <p:nvSpPr>
-          <p:cNvPr id="23" name="result card EDIT TO COMMIT"/>
-          <p:cNvSpPr/>
-          <p:nvPr/>
-        </p:nvSpPr>
-        <p:spPr>
-          <a:xfrm>
-            <a:off x="6035040" y="1188720"/>
-            <a:ext cx="2651760" cy="1325880"/>
+              <a:t>min / p50 / max, 3 runs, first draft valid (bench-qwen3.5_4b-1791049348895.json). 10 s target not met. 14 s once after normalization (RESULTS.md run 3).</a:t>
+            </a:r>
+            <a:endParaRPr lang="en-US" sz="750" dirty="0"/>
+          </a:p>
+        </p:txBody>
+      </p:sp>
+      <p:sp>
+        <p:nvSpPr>
+          <p:cNvPr id="23" name="result card COLD / CONTENDED GPU"/>
+          <p:cNvSpPr/>
+          <p:nvPr/>
+        </p:nvSpPr>
+        <p:spPr>
+          <a:xfrm>
+            <a:off x="6035040" y="1115568"/>
+            <a:ext cx="2651760" cy="987552"/>
           </a:xfrm>
           <a:prstGeom prst="roundRect">
             <a:avLst>
-              <a:gd name="adj" fmla="val 5517"/>
+              <a:gd name="adj" fmla="val 7407"/>
             </a:avLst>
           </a:prstGeom>
           <a:solidFill>
@@ -6786,14 +6786,14 @@
       </p:sp>
       <p:sp>
         <p:nvSpPr>
-          <p:cNvPr id="24" name="label EDIT TO COMMIT"/>
+          <p:cNvPr id="24" name="label COLD / CONTENDED GPU"/>
           <p:cNvSpPr txBox="1"/>
           <p:nvPr/>
         </p:nvSpPr>
         <p:spPr>
           <a:xfrm>
-            <a:off x="6199632" y="1316736"/>
-            <a:ext cx="2322576" cy="228600"/>
+            <a:off x="6181344" y="1188720"/>
+            <a:ext cx="2359152" cy="182880"/>
           </a:xfrm>
           <a:prstGeom prst="rect">
             <a:avLst/>
@@ -6809,27 +6809,27 @@
               <a:buNone/>
             </a:pPr>
             <a:r>
-              <a:rPr lang="en-US" sz="1000" b="1" spc="200" kern="0" dirty="0">
+              <a:rPr lang="en-US" sz="900" b="1" spc="200" kern="0" dirty="0">
                 <a:solidFill>
                   <a:schemeClr val="accent1"/>
                 </a:solidFill>
               </a:rPr>
-              <a:t>EDIT TO COMMIT</a:t>
-            </a:r>
-            <a:endParaRPr lang="en-US" sz="1000" dirty="0"/>
-          </a:p>
-        </p:txBody>
-      </p:sp>
-      <p:sp>
-        <p:nvSpPr>
-          <p:cNvPr id="25" name="result value EDIT TO COMMIT"/>
+              <a:t>COLD / CONTENDED GPU</a:t>
+            </a:r>
+            <a:endParaRPr lang="en-US" sz="900" dirty="0"/>
+          </a:p>
+        </p:txBody>
+      </p:sp>
+      <p:sp>
+        <p:nvSpPr>
+          <p:cNvPr id="25" name="result value COLD / CONTENDED GPU"/>
           <p:cNvSpPr txBox="1"/>
           <p:nvPr/>
         </p:nvSpPr>
         <p:spPr>
           <a:xfrm>
-            <a:off x="6199632" y="1572768"/>
-            <a:ext cx="2322576" cy="548640"/>
+            <a:off x="6181344" y="1362456"/>
+            <a:ext cx="2359152" cy="274320"/>
           </a:xfrm>
           <a:prstGeom prst="rect">
             <a:avLst/>
@@ -6845,27 +6845,27 @@
               <a:buNone/>
             </a:pPr>
             <a:r>
-              <a:rPr lang="en-US" sz="1500" b="1" dirty="0">
+              <a:rPr lang="en-US" sz="1250" b="1" dirty="0">
                 <a:solidFill>
                   <a:schemeClr val="accent1"/>
                 </a:solidFill>
               </a:rPr>
-              <a:t>[min] / [p50] / [max] s</a:t>
-            </a:r>
-            <a:endParaRPr lang="en-US" sz="1500" dirty="0"/>
-          </a:p>
-        </p:txBody>
-      </p:sp>
-      <p:sp>
-        <p:nvSpPr>
-          <p:cNvPr id="26" name="result sub EDIT TO COMMIT"/>
+              <a:t>23.1 s load; 58 to 214 s</a:t>
+            </a:r>
+            <a:endParaRPr lang="en-US" sz="1250" dirty="0"/>
+          </a:p>
+        </p:txBody>
+      </p:sp>
+      <p:sp>
+        <p:nvSpPr>
+          <p:cNvPr id="26" name="result sub COLD / CONTENDED GPU"/>
           <p:cNvSpPr txBox="1"/>
           <p:nvPr/>
         </p:nvSpPr>
         <p:spPr>
           <a:xfrm>
-            <a:off x="6199632" y="2157984"/>
-            <a:ext cx="2322576" cy="347472"/>
+            <a:off x="6181344" y="1645920"/>
+            <a:ext cx="2359152" cy="438912"/>
           </a:xfrm>
           <a:prstGeom prst="rect">
             <a:avLst/>
@@ -6881,31 +6881,31 @@
               <a:buNone/>
             </a:pPr>
             <a:r>
-              <a:rPr lang="en-US" sz="1000" dirty="0">
+              <a:rPr lang="en-US" sz="750" dirty="0">
                 <a:solidFill>
                   <a:schemeClr val="tx2"/>
                 </a:solidFill>
               </a:rPr>
-              <a:t>edit request to committed version</a:t>
-            </a:r>
-            <a:endParaRPr lang="en-US" sz="1000" dirty="0"/>
-          </a:p>
-        </p:txBody>
-      </p:sp>
-      <p:sp>
-        <p:nvSpPr>
-          <p:cNvPr id="27" name="result card INVALID EDITS CAUGHT"/>
-          <p:cNvSpPr/>
-          <p:nvPr/>
-        </p:nvSpPr>
-        <p:spPr>
-          <a:xfrm>
-            <a:off x="457200" y="2679192"/>
-            <a:ext cx="2651760" cy="1325880"/>
+              <a:t>cold: 23.1 s model load in a 54.4 s first draft (probe-run.log). Contended: drafts 58.8 to 214.1 s, one edit 45.1 s (bench-qwen3.5_4b-1791050596040.json).</a:t>
+            </a:r>
+            <a:endParaRPr lang="en-US" sz="750" dirty="0"/>
+          </a:p>
+        </p:txBody>
+      </p:sp>
+      <p:sp>
+        <p:nvSpPr>
+          <p:cNvPr id="27" name="result card EDIT TO COMMIT"/>
+          <p:cNvSpPr/>
+          <p:nvPr/>
+        </p:nvSpPr>
+        <p:spPr>
+          <a:xfrm>
+            <a:off x="457200" y="2157984"/>
+            <a:ext cx="2651760" cy="987552"/>
           </a:xfrm>
           <a:prstGeom prst="roundRect">
             <a:avLst>
-              <a:gd name="adj" fmla="val 5517"/>
+              <a:gd name="adj" fmla="val 7407"/>
             </a:avLst>
           </a:prstGeom>
           <a:solidFill>
@@ -6921,14 +6921,14 @@
       </p:sp>
       <p:sp>
         <p:nvSpPr>
-          <p:cNvPr id="28" name="label INVALID EDITS CAUGHT"/>
+          <p:cNvPr id="28" name="label EDIT TO COMMIT"/>
           <p:cNvSpPr txBox="1"/>
           <p:nvPr/>
         </p:nvSpPr>
         <p:spPr>
           <a:xfrm>
-            <a:off x="621792" y="2807208"/>
-            <a:ext cx="2322576" cy="228600"/>
+            <a:off x="603504" y="2231136"/>
+            <a:ext cx="2359152" cy="182880"/>
           </a:xfrm>
           <a:prstGeom prst="rect">
             <a:avLst/>
@@ -6944,27 +6944,27 @@
               <a:buNone/>
             </a:pPr>
             <a:r>
-              <a:rPr lang="en-US" sz="1000" b="1" spc="200" kern="0" dirty="0">
+              <a:rPr lang="en-US" sz="900" b="1" spc="200" kern="0" dirty="0">
                 <a:solidFill>
                   <a:schemeClr val="accent1"/>
                 </a:solidFill>
               </a:rPr>
-              <a:t>INVALID EDITS CAUGHT</a:t>
-            </a:r>
-            <a:endParaRPr lang="en-US" sz="1000" dirty="0"/>
-          </a:p>
-        </p:txBody>
-      </p:sp>
-      <p:sp>
-        <p:nvSpPr>
-          <p:cNvPr id="29" name="result value INVALID EDITS CAUGHT"/>
+              <a:t>EDIT TO COMMIT</a:t>
+            </a:r>
+            <a:endParaRPr lang="en-US" sz="900" dirty="0"/>
+          </a:p>
+        </p:txBody>
+      </p:sp>
+      <p:sp>
+        <p:nvSpPr>
+          <p:cNvPr id="29" name="result value EDIT TO COMMIT"/>
           <p:cNvSpPr txBox="1"/>
           <p:nvPr/>
         </p:nvSpPr>
         <p:spPr>
           <a:xfrm>
-            <a:off x="621792" y="3063240"/>
-            <a:ext cx="2322576" cy="548640"/>
+            <a:off x="603504" y="2404872"/>
+            <a:ext cx="2359152" cy="274320"/>
           </a:xfrm>
           <a:prstGeom prst="rect">
             <a:avLst/>
@@ -6980,27 +6980,27 @@
               <a:buNone/>
             </a:pPr>
             <a:r>
-              <a:rPr lang="en-US" sz="1500" b="1" dirty="0">
+              <a:rPr lang="en-US" sz="1250" b="1" dirty="0">
                 <a:solidFill>
                   <a:schemeClr val="accent1"/>
                 </a:solidFill>
               </a:rPr>
-              <a:t>[caught] of [attempts]</a:t>
-            </a:r>
-            <a:endParaRPr lang="en-US" sz="1500" dirty="0"/>
-          </a:p>
-        </p:txBody>
-      </p:sp>
-      <p:sp>
-        <p:nvSpPr>
-          <p:cNvPr id="30" name="result sub INVALID EDITS CAUGHT"/>
+              <a:t>2.0 / 8.0 / 14.0 s</a:t>
+            </a:r>
+            <a:endParaRPr lang="en-US" sz="1250" dirty="0"/>
+          </a:p>
+        </p:txBody>
+      </p:sp>
+      <p:sp>
+        <p:nvSpPr>
+          <p:cNvPr id="30" name="result sub EDIT TO COMMIT"/>
           <p:cNvSpPr txBox="1"/>
           <p:nvPr/>
         </p:nvSpPr>
         <p:spPr>
           <a:xfrm>
-            <a:off x="621792" y="3648456"/>
-            <a:ext cx="2322576" cy="347472"/>
+            <a:off x="603504" y="2688336"/>
+            <a:ext cx="2359152" cy="438912"/>
           </a:xfrm>
           <a:prstGeom prst="rect">
             <a:avLst/>
@@ -7016,31 +7016,31 @@
               <a:buNone/>
             </a:pPr>
             <a:r>
-              <a:rPr lang="en-US" sz="1000" dirty="0">
+              <a:rPr lang="en-US" sz="750" dirty="0">
                 <a:solidFill>
                   <a:schemeClr val="tx2"/>
                 </a:solidFill>
               </a:rPr>
-              <a:t>repairs that succeeded: [repaired]</a:t>
-            </a:r>
-            <a:endParaRPr lang="en-US" sz="1000" dirty="0"/>
-          </a:p>
-        </p:txBody>
-      </p:sp>
-      <p:sp>
-        <p:nvSpPr>
-          <p:cNvPr id="31" name="result card SESSION CONTINUITY"/>
-          <p:cNvSpPr/>
-          <p:nvPr/>
-        </p:nvSpPr>
-        <p:spPr>
-          <a:xfrm>
-            <a:off x="3246120" y="2679192"/>
-            <a:ext cx="2651760" cy="1325880"/>
+              <a:t>min / p50 / max, 6 edits, 5 of 6 committed; run 3 after normalization, quiet GPU, direct mode (run-1791052136845.json). Run 2 before: 2 of 6, 3.0 s each.</a:t>
+            </a:r>
+            <a:endParaRPr lang="en-US" sz="750" dirty="0"/>
+          </a:p>
+        </p:txBody>
+      </p:sp>
+      <p:sp>
+        <p:nvSpPr>
+          <p:cNvPr id="31" name="result card INVALID EDITS CAUGHT"/>
+          <p:cNvSpPr/>
+          <p:nvPr/>
+        </p:nvSpPr>
+        <p:spPr>
+          <a:xfrm>
+            <a:off x="3246120" y="2157984"/>
+            <a:ext cx="2651760" cy="987552"/>
           </a:xfrm>
           <a:prstGeom prst="roundRect">
             <a:avLst>
-              <a:gd name="adj" fmla="val 5517"/>
+              <a:gd name="adj" fmla="val 7407"/>
             </a:avLst>
           </a:prstGeom>
           <a:solidFill>
@@ -7056,14 +7056,14 @@
       </p:sp>
       <p:sp>
         <p:nvSpPr>
-          <p:cNvPr id="32" name="label SESSION CONTINUITY"/>
+          <p:cNvPr id="32" name="label INVALID EDITS CAUGHT"/>
           <p:cNvSpPr txBox="1"/>
           <p:nvPr/>
         </p:nvSpPr>
         <p:spPr>
           <a:xfrm>
-            <a:off x="3410712" y="2807208"/>
-            <a:ext cx="2322576" cy="228600"/>
+            <a:off x="3392424" y="2231136"/>
+            <a:ext cx="2359152" cy="182880"/>
           </a:xfrm>
           <a:prstGeom prst="rect">
             <a:avLst/>
@@ -7079,27 +7079,27 @@
               <a:buNone/>
             </a:pPr>
             <a:r>
-              <a:rPr lang="en-US" sz="1000" b="1" spc="200" kern="0" dirty="0">
+              <a:rPr lang="en-US" sz="900" b="1" spc="200" kern="0" dirty="0">
                 <a:solidFill>
                   <a:schemeClr val="accent1"/>
                 </a:solidFill>
               </a:rPr>
-              <a:t>SESSION CONTINUITY</a:t>
-            </a:r>
-            <a:endParaRPr lang="en-US" sz="1000" dirty="0"/>
-          </a:p>
-        </p:txBody>
-      </p:sp>
-      <p:sp>
-        <p:nvSpPr>
-          <p:cNvPr id="33" name="result value SESSION CONTINUITY"/>
+              <a:t>INVALID EDITS CAUGHT</a:t>
+            </a:r>
+            <a:endParaRPr lang="en-US" sz="900" dirty="0"/>
+          </a:p>
+        </p:txBody>
+      </p:sp>
+      <p:sp>
+        <p:nvSpPr>
+          <p:cNvPr id="33" name="result value INVALID EDITS CAUGHT"/>
           <p:cNvSpPr txBox="1"/>
           <p:nvPr/>
         </p:nvSpPr>
         <p:spPr>
           <a:xfrm>
-            <a:off x="3410712" y="3063240"/>
-            <a:ext cx="2322576" cy="548640"/>
+            <a:off x="3392424" y="2404872"/>
+            <a:ext cx="2359152" cy="274320"/>
           </a:xfrm>
           <a:prstGeom prst="rect">
             <a:avLst/>
@@ -7115,27 +7115,27 @@
               <a:buNone/>
             </a:pPr>
             <a:r>
-              <a:rPr lang="en-US" sz="1500" b="1" dirty="0">
+              <a:rPr lang="en-US" sz="1250" b="1" dirty="0">
                 <a:solidFill>
                   <a:schemeClr val="accent1"/>
                 </a:solidFill>
               </a:rPr>
-              <a:t>[players kept] players, [relics kept] relics</a:t>
-            </a:r>
-            <a:endParaRPr lang="en-US" sz="1500" dirty="0"/>
-          </a:p>
-        </p:txBody>
-      </p:sp>
-      <p:sp>
-        <p:nvSpPr>
-          <p:cNvPr id="34" name="result sub SESSION CONTINUITY"/>
+              <a:t>6 of 12 refused</a:t>
+            </a:r>
+            <a:endParaRPr lang="en-US" sz="1250" dirty="0"/>
+          </a:p>
+        </p:txBody>
+      </p:sp>
+      <p:sp>
+        <p:nvSpPr>
+          <p:cNvPr id="34" name="result sub INVALID EDITS CAUGHT"/>
           <p:cNvSpPr txBox="1"/>
           <p:nvPr/>
         </p:nvSpPr>
         <p:spPr>
           <a:xfrm>
-            <a:off x="3410712" y="3648456"/>
-            <a:ext cx="2322576" cy="347472"/>
+            <a:off x="3392424" y="2688336"/>
+            <a:ext cx="2359152" cy="438912"/>
           </a:xfrm>
           <a:prstGeom prst="rect">
             <a:avLst/>
@@ -7151,31 +7151,31 @@
               <a:buNone/>
             </a:pPr>
             <a:r>
-              <a:rPr lang="en-US" sz="1000" dirty="0">
+              <a:rPr lang="en-US" sz="750" dirty="0">
                 <a:solidFill>
                   <a:schemeClr val="tx2"/>
                 </a:solidFill>
               </a:rPr>
-              <a:t>[reconnects] reconnects across [N commits] commits</a:t>
-            </a:r>
-            <a:endParaRPr lang="en-US" sz="1000" dirty="0"/>
-          </a:p>
-        </p:txBody>
-      </p:sp>
-      <p:sp>
-        <p:nvSpPr>
-          <p:cNvPr id="35" name="result card OFFLINE PROOF"/>
-          <p:cNvSpPr/>
-          <p:nvPr/>
-        </p:nvSpPr>
-        <p:spPr>
-          <a:xfrm>
-            <a:off x="6035040" y="2679192"/>
-            <a:ext cx="2651760" cy="1325880"/>
+              <a:t>runs 2 and 3 (RESULTS.md); repairs that then committed: 1 (run 3 E6); invalid worlds committed: 0. On garden5 a DISCONNECTED_GOAL refusal was repaired and committed in 3.0 s.</a:t>
+            </a:r>
+            <a:endParaRPr lang="en-US" sz="750" dirty="0"/>
+          </a:p>
+        </p:txBody>
+      </p:sp>
+      <p:sp>
+        <p:nvSpPr>
+          <p:cNvPr id="35" name="result card NORMALIZATION EFFECT"/>
+          <p:cNvSpPr/>
+          <p:nvPr/>
+        </p:nvSpPr>
+        <p:spPr>
+          <a:xfrm>
+            <a:off x="6035040" y="2157984"/>
+            <a:ext cx="2651760" cy="987552"/>
           </a:xfrm>
           <a:prstGeom prst="roundRect">
             <a:avLst>
-              <a:gd name="adj" fmla="val 5517"/>
+              <a:gd name="adj" fmla="val 7407"/>
             </a:avLst>
           </a:prstGeom>
           <a:solidFill>
@@ -7191,14 +7191,14 @@
       </p:sp>
       <p:sp>
         <p:nvSpPr>
-          <p:cNvPr id="36" name="label OFFLINE PROOF"/>
+          <p:cNvPr id="36" name="label NORMALIZATION EFFECT"/>
           <p:cNvSpPr txBox="1"/>
           <p:nvPr/>
         </p:nvSpPr>
         <p:spPr>
           <a:xfrm>
-            <a:off x="6199632" y="2807208"/>
-            <a:ext cx="2322576" cy="228600"/>
+            <a:off x="6181344" y="2231136"/>
+            <a:ext cx="2359152" cy="182880"/>
           </a:xfrm>
           <a:prstGeom prst="rect">
             <a:avLst/>
@@ -7214,27 +7214,432 @@
               <a:buNone/>
             </a:pPr>
             <a:r>
-              <a:rPr lang="en-US" sz="1000" b="1" spc="200" kern="0" dirty="0">
+              <a:rPr lang="en-US" sz="900" b="1" spc="200" kern="0" dirty="0">
                 <a:solidFill>
                   <a:schemeClr val="accent1"/>
                 </a:solidFill>
               </a:rPr>
+              <a:t>NORMALIZATION EFFECT</a:t>
+            </a:r>
+            <a:endParaRPr lang="en-US" sz="900" dirty="0"/>
+          </a:p>
+        </p:txBody>
+      </p:sp>
+      <p:sp>
+        <p:nvSpPr>
+          <p:cNvPr id="37" name="result value NORMALIZATION EFFECT"/>
+          <p:cNvSpPr txBox="1"/>
+          <p:nvPr/>
+        </p:nvSpPr>
+        <p:spPr>
+          <a:xfrm>
+            <a:off x="6181344" y="2404872"/>
+            <a:ext cx="2359152" cy="274320"/>
+          </a:xfrm>
+          <a:prstGeom prst="rect">
+            <a:avLst/>
+          </a:prstGeom>
+          <a:noFill/>
+          <a:ln/>
+        </p:spPr>
+        <p:txBody>
+          <a:bodyPr wrap="square" lIns="0" tIns="0" rIns="0" bIns="0" rtlCol="0" anchor="ctr"/>
+          <a:lstStyle/>
+          <a:p>
+            <a:pPr indent="0" marL="0">
+              <a:buNone/>
+            </a:pPr>
+            <a:r>
+              <a:rPr lang="en-US" sz="1250" b="1" dirty="0">
+                <a:solidFill>
+                  <a:schemeClr val="accent1"/>
+                </a:solidFill>
+              </a:rPr>
+              <a:t>2 of 30 to 13 of 30</a:t>
+            </a:r>
+            <a:endParaRPr lang="en-US" sz="1250" dirty="0"/>
+          </a:p>
+        </p:txBody>
+      </p:sp>
+      <p:sp>
+        <p:nvSpPr>
+          <p:cNvPr id="38" name="result sub NORMALIZATION EFFECT"/>
+          <p:cNvSpPr txBox="1"/>
+          <p:nvPr/>
+        </p:nvSpPr>
+        <p:spPr>
+          <a:xfrm>
+            <a:off x="6181344" y="2688336"/>
+            <a:ext cx="2359152" cy="438912"/>
+          </a:xfrm>
+          <a:prstGeom prst="rect">
+            <a:avLst/>
+          </a:prstGeom>
+          <a:noFill/>
+          <a:ln/>
+        </p:spPr>
+        <p:txBody>
+          <a:bodyPr wrap="square" lIns="0" tIns="0" rIns="0" bIns="0" rtlCol="0" anchor="t"/>
+          <a:lstStyle/>
+          <a:p>
+            <a:pPr indent="0" marL="0">
+              <a:buNone/>
+            </a:pPr>
+            <a:r>
+              <a:rPr lang="en-US" sz="750" dirty="0">
+                <a:solidFill>
+                  <a:schemeClr val="tx2"/>
+                </a:solidFill>
+              </a:rPr>
+              <a:t>corpus validity without vs with the deterministic normalizer (MODEL_FAILURE_MODES.md, corpus/summary.json). Live edits committed: 2 of 6 to 5 of 6.</a:t>
+            </a:r>
+            <a:endParaRPr lang="en-US" sz="750" dirty="0"/>
+          </a:p>
+        </p:txBody>
+      </p:sp>
+      <p:sp>
+        <p:nvSpPr>
+          <p:cNvPr id="39" name="result card LATENCY, LOOPBACK"/>
+          <p:cNvSpPr/>
+          <p:nvPr/>
+        </p:nvSpPr>
+        <p:spPr>
+          <a:xfrm>
+            <a:off x="457200" y="3200400"/>
+            <a:ext cx="2651760" cy="987552"/>
+          </a:xfrm>
+          <a:prstGeom prst="roundRect">
+            <a:avLst>
+              <a:gd name="adj" fmla="val 7407"/>
+            </a:avLst>
+          </a:prstGeom>
+          <a:solidFill>
+            <a:schemeClr val="bg2"/>
+          </a:solidFill>
+          <a:ln w="9525">
+            <a:solidFill>
+              <a:schemeClr val="accent4"/>
+            </a:solidFill>
+            <a:prstDash val="solid"/>
+          </a:ln>
+        </p:spPr>
+      </p:sp>
+      <p:sp>
+        <p:nvSpPr>
+          <p:cNvPr id="40" name="label LATENCY, LOOPBACK"/>
+          <p:cNvSpPr txBox="1"/>
+          <p:nvPr/>
+        </p:nvSpPr>
+        <p:spPr>
+          <a:xfrm>
+            <a:off x="603504" y="3273552"/>
+            <a:ext cx="2359152" cy="182880"/>
+          </a:xfrm>
+          <a:prstGeom prst="rect">
+            <a:avLst/>
+          </a:prstGeom>
+          <a:noFill/>
+          <a:ln/>
+        </p:spPr>
+        <p:txBody>
+          <a:bodyPr wrap="square" lIns="0" tIns="0" rIns="0" bIns="0" rtlCol="0" anchor="ctr"/>
+          <a:lstStyle/>
+          <a:p>
+            <a:pPr indent="0" marL="0">
+              <a:buNone/>
+            </a:pPr>
+            <a:r>
+              <a:rPr lang="en-US" sz="900" b="1" spc="200" kern="0" dirty="0">
+                <a:solidFill>
+                  <a:schemeClr val="accent1"/>
+                </a:solidFill>
+              </a:rPr>
+              <a:t>LATENCY, LOOPBACK</a:t>
+            </a:r>
+            <a:endParaRPr lang="en-US" sz="900" dirty="0"/>
+          </a:p>
+        </p:txBody>
+      </p:sp>
+      <p:sp>
+        <p:nvSpPr>
+          <p:cNvPr id="41" name="result value LATENCY, LOOPBACK"/>
+          <p:cNvSpPr txBox="1"/>
+          <p:nvPr/>
+        </p:nvSpPr>
+        <p:spPr>
+          <a:xfrm>
+            <a:off x="603504" y="3447288"/>
+            <a:ext cx="2359152" cy="274320"/>
+          </a:xfrm>
+          <a:prstGeom prst="rect">
+            <a:avLst/>
+          </a:prstGeom>
+          <a:noFill/>
+          <a:ln/>
+        </p:spPr>
+        <p:txBody>
+          <a:bodyPr wrap="square" lIns="0" tIns="0" rIns="0" bIns="0" rtlCol="0" anchor="ctr"/>
+          <a:lstStyle/>
+          <a:p>
+            <a:pPr indent="0" marL="0">
+              <a:buNone/>
+            </a:pPr>
+            <a:r>
+              <a:rPr lang="en-US" sz="1250" b="1" dirty="0">
+                <a:solidFill>
+                  <a:schemeClr val="accent1"/>
+                </a:solidFill>
+              </a:rPr>
+              <a:t>0.48 ms RTT, 18.8 ms tick</a:t>
+            </a:r>
+            <a:endParaRPr lang="en-US" sz="1250" dirty="0"/>
+          </a:p>
+        </p:txBody>
+      </p:sp>
+      <p:sp>
+        <p:nvSpPr>
+          <p:cNvPr id="42" name="result sub LATENCY, LOOPBACK"/>
+          <p:cNvSpPr txBox="1"/>
+          <p:nvPr/>
+        </p:nvSpPr>
+        <p:spPr>
+          <a:xfrm>
+            <a:off x="603504" y="3730752"/>
+            <a:ext cx="2359152" cy="438912"/>
+          </a:xfrm>
+          <a:prstGeom prst="rect">
+            <a:avLst/>
+          </a:prstGeom>
+          <a:noFill/>
+          <a:ln/>
+        </p:spPr>
+        <p:txBody>
+          <a:bodyPr wrap="square" lIns="0" tIns="0" rIns="0" bIns="0" rtlCol="0" anchor="t"/>
+          <a:lstStyle/>
+          <a:p>
+            <a:pPr indent="0" marL="0">
+              <a:buNone/>
+            </a:pPr>
+            <a:r>
+              <a:rPr lang="en-US" sz="750" dirty="0">
+                <a:solidFill>
+                  <a:schemeClr val="tx2"/>
+                </a:solidFill>
+              </a:rPr>
+              <a:t>p50, scripted controllers (p95 0.81 and 33.1 ms; LATENCY.md). Not input to photon: no phone, Wi-Fi, browser or display included.</a:t>
+            </a:r>
+            <a:endParaRPr lang="en-US" sz="750" dirty="0"/>
+          </a:p>
+        </p:txBody>
+      </p:sp>
+      <p:sp>
+        <p:nvSpPr>
+          <p:cNvPr id="43" name="result card SESSION CONTINUITY"/>
+          <p:cNvSpPr/>
+          <p:nvPr/>
+        </p:nvSpPr>
+        <p:spPr>
+          <a:xfrm>
+            <a:off x="3246120" y="3200400"/>
+            <a:ext cx="2651760" cy="987552"/>
+          </a:xfrm>
+          <a:prstGeom prst="roundRect">
+            <a:avLst>
+              <a:gd name="adj" fmla="val 7407"/>
+            </a:avLst>
+          </a:prstGeom>
+          <a:solidFill>
+            <a:schemeClr val="bg2"/>
+          </a:solidFill>
+          <a:ln w="9525">
+            <a:solidFill>
+              <a:schemeClr val="accent4"/>
+            </a:solidFill>
+            <a:prstDash val="solid"/>
+          </a:ln>
+        </p:spPr>
+      </p:sp>
+      <p:sp>
+        <p:nvSpPr>
+          <p:cNvPr id="44" name="label SESSION CONTINUITY"/>
+          <p:cNvSpPr txBox="1"/>
+          <p:nvPr/>
+        </p:nvSpPr>
+        <p:spPr>
+          <a:xfrm>
+            <a:off x="3392424" y="3273552"/>
+            <a:ext cx="2359152" cy="182880"/>
+          </a:xfrm>
+          <a:prstGeom prst="rect">
+            <a:avLst/>
+          </a:prstGeom>
+          <a:noFill/>
+          <a:ln/>
+        </p:spPr>
+        <p:txBody>
+          <a:bodyPr wrap="square" lIns="0" tIns="0" rIns="0" bIns="0" rtlCol="0" anchor="ctr"/>
+          <a:lstStyle/>
+          <a:p>
+            <a:pPr indent="0" marL="0">
+              <a:buNone/>
+            </a:pPr>
+            <a:r>
+              <a:rPr lang="en-US" sz="900" b="1" spc="200" kern="0" dirty="0">
+                <a:solidFill>
+                  <a:schemeClr val="accent1"/>
+                </a:solidFill>
+              </a:rPr>
+              <a:t>SESSION CONTINUITY</a:t>
+            </a:r>
+            <a:endParaRPr lang="en-US" sz="900" dirty="0"/>
+          </a:p>
+        </p:txBody>
+      </p:sp>
+      <p:sp>
+        <p:nvSpPr>
+          <p:cNvPr id="45" name="result value SESSION CONTINUITY"/>
+          <p:cNvSpPr txBox="1"/>
+          <p:nvPr/>
+        </p:nvSpPr>
+        <p:spPr>
+          <a:xfrm>
+            <a:off x="3392424" y="3447288"/>
+            <a:ext cx="2359152" cy="274320"/>
+          </a:xfrm>
+          <a:prstGeom prst="rect">
+            <a:avLst/>
+          </a:prstGeom>
+          <a:noFill/>
+          <a:ln/>
+        </p:spPr>
+        <p:txBody>
+          <a:bodyPr wrap="square" lIns="0" tIns="0" rIns="0" bIns="0" rtlCol="0" anchor="ctr"/>
+          <a:lstStyle/>
+          <a:p>
+            <a:pPr indent="0" marL="0">
+              <a:buNone/>
+            </a:pPr>
+            <a:r>
+              <a:rPr lang="en-US" sz="1250" b="1" dirty="0">
+                <a:solidFill>
+                  <a:schemeClr val="accent1"/>
+                </a:solidFill>
+              </a:rPr>
+              <a:t>not measured live</a:t>
+            </a:r>
+            <a:endParaRPr lang="en-US" sz="1250" dirty="0"/>
+          </a:p>
+        </p:txBody>
+      </p:sp>
+      <p:sp>
+        <p:nvSpPr>
+          <p:cNvPr id="46" name="result sub SESSION CONTINUITY"/>
+          <p:cNvSpPr txBox="1"/>
+          <p:nvPr/>
+        </p:nvSpPr>
+        <p:spPr>
+          <a:xfrm>
+            <a:off x="3392424" y="3730752"/>
+            <a:ext cx="2359152" cy="438912"/>
+          </a:xfrm>
+          <a:prstGeom prst="rect">
+            <a:avLst/>
+          </a:prstGeom>
+          <a:noFill/>
+          <a:ln/>
+        </p:spPr>
+        <p:txBody>
+          <a:bodyPr wrap="square" lIns="0" tIns="0" rIns="0" bIns="0" rtlCol="0" anchor="t"/>
+          <a:lstStyle/>
+          <a:p>
+            <a:pPr indent="0" marL="0">
+              <a:buNone/>
+            </a:pPr>
+            <a:r>
+              <a:rPr lang="en-US" sz="750" dirty="0">
+                <a:solidFill>
+                  <a:schemeClr val="tx2"/>
+                </a:solidFill>
+              </a:rPr>
+              <a:t>no player connected in runs 2 and 3. Preserved ids, relics, score and reconnect are covered by integration tests with real sockets (BUILD_STATUS.md 10, 12).</a:t>
+            </a:r>
+            <a:endParaRPr lang="en-US" sz="750" dirty="0"/>
+          </a:p>
+        </p:txBody>
+      </p:sp>
+      <p:sp>
+        <p:nvSpPr>
+          <p:cNvPr id="47" name="result card OFFLINE PROOF"/>
+          <p:cNvSpPr/>
+          <p:nvPr/>
+        </p:nvSpPr>
+        <p:spPr>
+          <a:xfrm>
+            <a:off x="6035040" y="3200400"/>
+            <a:ext cx="2651760" cy="987552"/>
+          </a:xfrm>
+          <a:prstGeom prst="roundRect">
+            <a:avLst>
+              <a:gd name="adj" fmla="val 7407"/>
+            </a:avLst>
+          </a:prstGeom>
+          <a:solidFill>
+            <a:schemeClr val="bg2"/>
+          </a:solidFill>
+          <a:ln w="9525">
+            <a:solidFill>
+              <a:schemeClr val="accent4"/>
+            </a:solidFill>
+            <a:prstDash val="solid"/>
+          </a:ln>
+        </p:spPr>
+      </p:sp>
+      <p:sp>
+        <p:nvSpPr>
+          <p:cNvPr id="48" name="label OFFLINE PROOF"/>
+          <p:cNvSpPr txBox="1"/>
+          <p:nvPr/>
+        </p:nvSpPr>
+        <p:spPr>
+          <a:xfrm>
+            <a:off x="6181344" y="3273552"/>
+            <a:ext cx="2359152" cy="182880"/>
+          </a:xfrm>
+          <a:prstGeom prst="rect">
+            <a:avLst/>
+          </a:prstGeom>
+          <a:noFill/>
+          <a:ln/>
+        </p:spPr>
+        <p:txBody>
+          <a:bodyPr wrap="square" lIns="0" tIns="0" rIns="0" bIns="0" rtlCol="0" anchor="ctr"/>
+          <a:lstStyle/>
+          <a:p>
+            <a:pPr indent="0" marL="0">
+              <a:buNone/>
+            </a:pPr>
+            <a:r>
+              <a:rPr lang="en-US" sz="900" b="1" spc="200" kern="0" dirty="0">
+                <a:solidFill>
+                  <a:schemeClr val="accent1"/>
+                </a:solidFill>
+              </a:rPr>
               <a:t>OFFLINE PROOF</a:t>
             </a:r>
-            <a:endParaRPr lang="en-US" sz="1000" dirty="0"/>
-          </a:p>
-        </p:txBody>
-      </p:sp>
-      <p:sp>
-        <p:nvSpPr>
-          <p:cNvPr id="37" name="result value OFFLINE PROOF"/>
+            <a:endParaRPr lang="en-US" sz="900" dirty="0"/>
+          </a:p>
+        </p:txBody>
+      </p:sp>
+      <p:sp>
+        <p:nvSpPr>
+          <p:cNvPr id="49" name="result value OFFLINE PROOF"/>
           <p:cNvSpPr txBox="1"/>
           <p:nvPr/>
         </p:nvSpPr>
         <p:spPr>
           <a:xfrm>
-            <a:off x="6199632" y="3063240"/>
-            <a:ext cx="2322576" cy="548640"/>
+            <a:off x="6181344" y="3447288"/>
+            <a:ext cx="2359152" cy="274320"/>
           </a:xfrm>
           <a:prstGeom prst="rect">
             <a:avLst/>
@@ -7250,27 +7655,27 @@
               <a:buNone/>
             </a:pPr>
             <a:r>
-              <a:rPr lang="en-US" sz="1500" b="1" dirty="0">
+              <a:rPr lang="en-US" sz="1250" b="1" dirty="0">
                 <a:solidFill>
                   <a:schemeClr val="accent1"/>
                 </a:solidFill>
               </a:rPr>
-              <a:t>[what was disconnected]</a:t>
-            </a:r>
-            <a:endParaRPr lang="en-US" sz="1500" dirty="0"/>
-          </a:p>
-        </p:txBody>
-      </p:sp>
-      <p:sp>
-        <p:nvSpPr>
-          <p:cNvPr id="38" name="result sub OFFLINE PROOF"/>
+              <a:t>not run</a:t>
+            </a:r>
+            <a:endParaRPr lang="en-US" sz="1250" dirty="0"/>
+          </a:p>
+        </p:txBody>
+      </p:sp>
+      <p:sp>
+        <p:nvSpPr>
+          <p:cNvPr id="50" name="result sub OFFLINE PROOF"/>
           <p:cNvSpPr txBox="1"/>
           <p:nvPr/>
         </p:nvSpPr>
         <p:spPr>
           <a:xfrm>
-            <a:off x="6199632" y="3648456"/>
-            <a:ext cx="2322576" cy="347472"/>
+            <a:off x="6181344" y="3730752"/>
+            <a:ext cx="2359152" cy="438912"/>
           </a:xfrm>
           <a:prstGeom prst="rect">
             <a:avLst/>
@@ -7286,27 +7691,27 @@
               <a:buNone/>
             </a:pPr>
             <a:r>
-              <a:rPr lang="en-US" sz="1000" dirty="0">
+              <a:rPr lang="en-US" sz="750" dirty="0">
                 <a:solidFill>
                   <a:schemeClr val="tx2"/>
                 </a:solidFill>
               </a:rPr>
-              <a:t>still worked: [what still worked]</a:t>
-            </a:r>
-            <a:endParaRPr lang="en-US" sz="1000" dirty="0"/>
-          </a:p>
-        </p:txBody>
-      </p:sp>
-      <p:sp>
-        <p:nvSpPr>
-          <p:cNvPr id="39" name="placeholder note"/>
+              <a:t>only a before record exists (data/offline-proof/1791049273707.json: egress not blocked, server not up). Procedure: docs/OFFLINE_PROOF.md. Nothing claimed.</a:t>
+            </a:r>
+            <a:endParaRPr lang="en-US" sz="750" dirty="0"/>
+          </a:p>
+        </p:txBody>
+      </p:sp>
+      <p:sp>
+        <p:nvSpPr>
+          <p:cNvPr id="51" name="sources note"/>
           <p:cNvSpPr txBox="1"/>
           <p:nvPr/>
         </p:nvSpPr>
         <p:spPr>
           <a:xfrm>
-            <a:off x="457200" y="4224528"/>
-            <a:ext cx="8229600" cy="411480"/>
+            <a:off x="457200" y="4261104"/>
+            <a:ext cx="8229600" cy="420624"/>
           </a:xfrm>
           <a:prstGeom prst="rect">
             <a:avLst/>
@@ -7322,14 +7727,14 @@
               <a:buNone/>
             </a:pPr>
             <a:r>
-              <a:rPr lang="en-US" sz="1000" i="1" dirty="0">
+              <a:rPr lang="en-US" sz="850" i="1" dirty="0">
                 <a:solidFill>
                   <a:schemeClr val="tx2"/>
                 </a:solidFill>
               </a:rPr>
-              <a:t>Every bracketed value is a placeholder. Values come only from data/benchmarks/*.json and data/reports/*.json. Nothing unmeasured goes on a slide.</a:t>
-            </a:r>
-            <a:endParaRPr lang="en-US" sz="1000" dirty="0"/>
+              <a:t>All timings are from the direct harness, labelled [direct] in every report, and each names its GPU state because the Ollama daemon was shared for most of the day. OpenClaw tool calls are proven against a fake server (packages/agent/SMOKE.md); the run against the real server times out before any model call and is being diagnosed.</a:t>
+            </a:r>
+            <a:endParaRPr lang="en-US" sz="850" dirty="0"/>
           </a:p>
         </p:txBody>
       </p:sp>

</xml_diff>

<commit_message>
Docs: measured mode briefs in the deck, README, runbook and storyboard
</commit_message>
<xml_diff>
--- a/docs/pitch/Beetle-pitch.pptx
+++ b/docs/pitch/Beetle-pitch.pptx
@@ -112,7 +112,7 @@
   <p:extLst>
     <p:ext uri="{521415D9-36F7-43E2-AB2F-B90AF26B5E84}">
       <p14:sectionLst xmlns:p14="http://schemas.microsoft.com/office/powerpoint/2010/main">
-        <p14:section name="Beetle pitch" id="{06e9093f-b94e-6cb6-84bc-101b2dbec484}">
+        <p14:section name="Beetle pitch" id="{3394f850-dde4-6cf3-fb0c-626576b26631}">
           <p14:sldIdLst>
             <p14:sldId id="256"/>
             <p14:sldId id="257"/>
@@ -614,7 +614,7 @@
           <a:p>
             <a:r>
               <a:rPr lang="en-US" dirty="0"/>
-              <a:t>Walk the four steps: any request, mapped to the closest mode and biome and named, a playable world two phones join, then keep changing it while they play. Read two rows of the mode table, not all five. Say plainly: the library is bounded and growing; the model never writes rules, it picks from the engine. Status at 14:27 CDT: contract, validator, patch ops, server rule per mode, mapping prompt and biome palettes exist in code; BUILD_STATUS.md says what is tested; mode briefs are not measured yet (slide 5).</a:t>
+              <a:t>Walk the four steps: any request, mapped to the closest mode and biome and named, a playable world two phones join, then keep changing it while they play. Read two rows of the mode table, not all five. Say plainly: the library is bounded and growing; the model never writes rules, it picks from the engine. Status at 14:27 CDT: contract, validator, patch ops, server rule per mode, mapping prompt and biome palettes exist in code; BUILD_STATUS.md says what is tested; mode briefs measured 14:25 to 14:42 CDT, 18 of 18 sensible modes (slide 5).</a:t>
             </a:r>
             <a:endParaRPr lang="en-US" dirty="0"/>
           </a:p>
@@ -878,7 +878,7 @@
           <a:p>
             <a:r>
               <a:rPr lang="en-US" dirty="0"/>
-              <a:t>Read the cards. Say out loud: the 10 s brief target is not met; a valid brief takes 24 to 28 s warm on a quiet GPU, 14 s was seen once after normalization, 33.4 s through OpenClaw. Edits commit in 2 to 14 s, and 8.0 s with two players moving and nothing reset. Game modes from one prompt are not yet measured; say so rather than guessing. Phones and the offline proof are covered by tests or procedure but not yet measured live. The 27b was never benchmarked.</a:t>
+              <a:t>Read the cards. Say out loud: the 10 s brief target is not met; a valid brief takes 24 to 28 s warm on a quiet GPU, 14 s was seen once after normalization, 33.4 s through OpenClaw. Edits commit in 2 to 14 s, and 8.0 s with two players moving and nothing reset. Game modes from one prompt: the mode was sensible on 18 of 18 briefs and the exact mode was missed twice; committed mode briefs took 13 to 44 s and the failures were geometry, never the mode rule; mode and biome edits on a running world took 3.0 s. Phones and the offline proof are covered by tests or procedure but not yet measured live. The 27b was never benchmarked.</a:t>
             </a:r>
             <a:endParaRPr lang="en-US" dirty="0"/>
           </a:p>
@@ -8239,7 +8239,7 @@
       </p:sp>
       <p:sp>
         <p:nvSpPr>
-          <p:cNvPr id="23" name="result card MODE BRIEFS, ONE PROMPT"/>
+          <p:cNvPr id="23" name="result card MODE BRIEFS"/>
           <p:cNvSpPr/>
           <p:nvPr/>
         </p:nvSpPr>
@@ -8266,7 +8266,7 @@
       </p:sp>
       <p:sp>
         <p:nvSpPr>
-          <p:cNvPr id="24" name="label MODE BRIEFS, ONE PROMPT"/>
+          <p:cNvPr id="24" name="label MODE BRIEFS"/>
           <p:cNvSpPr txBox="1"/>
           <p:nvPr/>
         </p:nvSpPr>
@@ -8294,7 +8294,7 @@
                   <a:schemeClr val="accent1"/>
                 </a:solidFill>
               </a:rPr>
-              <a:t>MODE BRIEFS, ONE PROMPT</a:t>
+              <a:t>MODE BRIEFS</a:t>
             </a:r>
             <a:endParaRPr lang="en-US" sz="750" dirty="0"/>
           </a:p>
@@ -8302,7 +8302,7 @@
       </p:sp>
       <p:sp>
         <p:nvSpPr>
-          <p:cNvPr id="25" name="result value MODE BRIEFS, ONE PROMPT"/>
+          <p:cNvPr id="25" name="result value MODE BRIEFS"/>
           <p:cNvSpPr txBox="1"/>
           <p:nvPr/>
         </p:nvSpPr>
@@ -8330,7 +8330,7 @@
                   <a:schemeClr val="accent1"/>
                 </a:solidFill>
               </a:rPr>
-              <a:t>not yet measured</a:t>
+              <a:t>18 of 18 right mode</a:t>
             </a:r>
             <a:endParaRPr lang="en-US" sz="1100" dirty="0"/>
           </a:p>
@@ -8338,7 +8338,7 @@
       </p:sp>
       <p:sp>
         <p:nvSpPr>
-          <p:cNvPr id="26" name="result sub MODE BRIEFS, ONE PROMPT"/>
+          <p:cNvPr id="26" name="result sub MODE BRIEFS"/>
           <p:cNvSpPr txBox="1"/>
           <p:nvPr/>
         </p:nvSpPr>
@@ -8366,7 +8366,7 @@
                   <a:schemeClr val="tx2"/>
                 </a:solidFill>
               </a:rPr>
-              <a:t>mode, biome and brief-to-commit per request are being appended to docs/RESULTS.md 'Game modes from one prompt'; this card is rebuilt from those rows only.</a:t>
+              <a:t>committed briefs 13.0 to 44.1 s; exact mode missed twice; 8 of 14 final-prompt attempts committed, failures all geometry; mode and biome edits 3.0 s (RESULTS.md 'Game modes from one prompt', direct).</a:t>
             </a:r>
             <a:endParaRPr lang="en-US" sz="680" dirty="0"/>
           </a:p>
@@ -9617,7 +9617,7 @@
                   <a:schemeClr val="tx2"/>
                 </a:solidFill>
               </a:rPr>
-              <a:t>Direct-harness timings are labelled [direct] in every report; OpenClaw timings are from the real server after the Ollama daemon restart at 13:43 CDT. Each card names its GPU state because the daemon was shared for most of the day. Mode briefs: not yet measured; the card is filled only from docs/RESULTS.md.</a:t>
+              <a:t>Direct-harness timings are labelled [direct] in every report; OpenClaw timings are from the real server after the Ollama daemon restart at 13:43 CDT. Each card names its GPU state because the daemon was shared for most of the day. Mode briefs were measured at 14:25 to 14:42 CDT in direct mode with no controllers connected (docs/RESULTS.md).</a:t>
             </a:r>
             <a:endParaRPr lang="en-US" sz="800" dirty="0"/>
           </a:p>

</xml_diff>

<commit_message>
Pitch: streaming generation with the live 9.5 s extension; competitive row; storyboard shot
</commit_message>
<xml_diff>
--- a/docs/pitch/Beetle-pitch.pptx
+++ b/docs/pitch/Beetle-pitch.pptx
@@ -112,7 +112,7 @@
   <p:extLst>
     <p:ext uri="{521415D9-36F7-43E2-AB2F-B90AF26B5E84}">
       <p14:sectionLst xmlns:p14="http://schemas.microsoft.com/office/powerpoint/2010/main">
-        <p14:section name="Beetle pitch" id="{3394f850-dde4-6cf3-fb0c-626576b26631}">
+        <p14:section name="Beetle pitch" id="{7efa93a3-c713-133a-0a0f-69940126bcf4}">
           <p14:sldIdLst>
             <p14:sldId id="256"/>
             <p14:sldId id="257"/>
@@ -614,7 +614,7 @@
           <a:p>
             <a:r>
               <a:rPr lang="en-US" dirty="0"/>
-              <a:t>Walk the four steps: any request, mapped to the closest mode and biome and named, a playable world two phones join, then keep changing it while they play. Read two rows of the mode table, not all five. Say plainly: the library is bounded and growing; the model never writes rules, it picks from the engine. Status at 14:27 CDT: contract, validator, patch ops, server rule per mode, mapping prompt and biome palettes exist in code; BUILD_STATUS.md says what is tested; mode briefs measured 14:25 to 14:42 CDT, 18 of 18 sensible modes (slide 5).</a:t>
+              <a:t>Walk the five steps: any request, mapped to the closest mode and biome and named; the world starts where the players are (the brief builds the zone around the spawn); it grows as they move, every extension a small patch validated before it lands; then keep changing it while they play. Read two rows of the mode table, not all five. Say plainly: the library is bounded and growing; the model never writes rules, it picks from the engine. Streaming was measured once: an automatic extension (two islands) committed 9.5 s after the frontier trigger with the player preserved (docs/RESULTS.md 15:16 CDT, direct, quiet GPU). Say 'measured once'; the spawn-zone brief time is not measured. Mode briefs measured 14:25 to 14:42 CDT, 18 of 18 sensible modes (slide 5).</a:t>
             </a:r>
             <a:endParaRPr lang="en-US" dirty="0"/>
           </a:p>
@@ -702,7 +702,7 @@
           <a:p>
             <a:r>
               <a:rPr lang="en-US" dirty="0"/>
-              <a:t>Play the recording here. Captions follow docs/STORYBOARD.md; the mode caption is set to whichever agent mode was green at recording time. Rehearsal timings: brief 14 s on a quiet GPU, edits 2 to 14 s, DISCONNECTED_GOAL refused and repaired in 3.0 s. Shots that cannot be produced honestly are cut, not faked.</a:t>
+              <a:t>Play the recording here. Captions follow docs/STORYBOARD.md; the mode caption is set to whichever agent mode was green at recording time. Rehearsal timings: brief 14 s on a quiet GPU, edits 2 to 14 s, DISCONNECTED_GOAL refused and repaired in 3.0 s. Shots that cannot be produced honestly are cut, not faked. Optional shot 'the world grows' (docs/STORYBOARD.md 6c): a player walks toward an edge, 'Beetle is building ahead' appears and the new island assembles; one live run committed an extension 9.5 s after the trigger (docs/RESULTS.md 15:16 CDT), not yet rehearsed on camera, so it is shown only from a real take, never compressed without a label.</a:t>
             </a:r>
             <a:endParaRPr lang="en-US" dirty="0"/>
           </a:p>
@@ -790,7 +790,7 @@
           <a:p>
             <a:r>
               <a:rPr lang="en-US" dirty="0"/>
-              <a:t>Left to right: director, OpenClaw agent, the mapping step (closest mode and biome, parameters from the brief, named in the summary), Beetle tools, server validator and commit, players. Structured output means only a listed mode, a listed biome and in-range parameters can come out of the model. Only the server decides validity; the model only proposes JSON.</a:t>
+              <a:t>Left to right: director or the frontier trigger, OpenClaw agent, the mapping step (closest mode and biome, parameters from the brief, named in the summary), Beetle tools, server validator and commit, players. Streaming uses the same path: when a player walks within 4 m of an island rim with no crossing beyond, Beetle opens an extension request itself, the agent proposes add_island (1 to 2 islands, each bridged from an anchor), and the same validator decides; growth stops at 24 islands and 48 bridges, and the director can switch it off. Structured output means only a listed mode, a listed biome and in-range parameters can come out of the model. Only the server decides validity; the model only proposes JSON.</a:t>
             </a:r>
             <a:endParaRPr lang="en-US" dirty="0"/>
           </a:p>
@@ -878,7 +878,7 @@
           <a:p>
             <a:r>
               <a:rPr lang="en-US" dirty="0"/>
-              <a:t>Read the cards. Say out loud: the 10 s brief target is not met; a valid brief takes 24 to 28 s warm on a quiet GPU, 14 s was seen once after normalization, 33.4 s through OpenClaw. Edits commit in 2 to 14 s, and 8.0 s with two players moving and nothing reset. Game modes from one prompt: the mode was sensible on 18 of 18 briefs and the exact mode was missed twice; committed mode briefs took 13 to 44 s and the failures were geometry, never the mode rule; mode and biome edits on a running world took 3.0 s. Phones and the offline proof are covered by tests or procedure but not yet measured live. The 27b was never benchmarked.</a:t>
+              <a:t>Read the cards. Say out loud: the 10 s brief target is not met; a valid brief takes 24 to 28 s warm on a quiet GPU, 14 s was seen once after normalization, 33.4 s through OpenClaw. Edits commit in 2 to 14 s, and 8.0 s with two players moving and nothing reset. Game modes from one prompt: the mode was sensible on 18 of 18 briefs and the exact mode was missed twice; committed mode briefs took 13 to 44 s and the failures were geometry, never the mode rule; mode and biome edits on a running world took 3.0 s. Phones and the offline proof are covered by tests or procedure but not yet measured live. Streaming generation is implemented and was measured once live: extension committed 9.5 s after the frontier trigger, player preserved (docs/RESULTS.md 15:16 CDT); say 'one run, acceptance numbers to follow'. No spawn-zone build time is quoted. The 27b was never benchmarked.</a:t>
             </a:r>
             <a:endParaRPr lang="en-US" dirty="0"/>
           </a:p>
@@ -3006,8 +3006,8 @@
         </p:nvSpPr>
         <p:spPr>
           <a:xfrm>
-            <a:off x="91440" y="1600200"/>
-            <a:ext cx="1920240" cy="685800"/>
+            <a:off x="228600" y="1600200"/>
+            <a:ext cx="1645920" cy="685800"/>
           </a:xfrm>
           <a:prstGeom prst="rect">
             <a:avLst/>
@@ -3059,7 +3059,7 @@
         </p:nvSpPr>
         <p:spPr>
           <a:xfrm>
-            <a:off x="3197352" y="1124712"/>
+            <a:off x="2610612" y="1124712"/>
             <a:ext cx="402336" cy="402336"/>
           </a:xfrm>
           <a:prstGeom prst="ellipse">
@@ -3084,7 +3084,7 @@
         </p:nvSpPr>
         <p:spPr>
           <a:xfrm>
-            <a:off x="3197352" y="1124712"/>
+            <a:off x="2610612" y="1124712"/>
             <a:ext cx="402336" cy="402336"/>
           </a:xfrm>
           <a:prstGeom prst="rect">
@@ -3120,8 +3120,8 @@
         </p:nvSpPr>
         <p:spPr>
           <a:xfrm>
-            <a:off x="2438400" y="1600200"/>
-            <a:ext cx="1920240" cy="685800"/>
+            <a:off x="1988820" y="1600200"/>
+            <a:ext cx="1645920" cy="685800"/>
           </a:xfrm>
           <a:prstGeom prst="rect">
             <a:avLst/>
@@ -3173,7 +3173,7 @@
         </p:nvSpPr>
         <p:spPr>
           <a:xfrm>
-            <a:off x="5544312" y="1124712"/>
+            <a:off x="4370832" y="1124712"/>
             <a:ext cx="402336" cy="402336"/>
           </a:xfrm>
           <a:prstGeom prst="ellipse">
@@ -3198,7 +3198,7 @@
         </p:nvSpPr>
         <p:spPr>
           <a:xfrm>
-            <a:off x="5544312" y="1124712"/>
+            <a:off x="4370832" y="1124712"/>
             <a:ext cx="402336" cy="402336"/>
           </a:xfrm>
           <a:prstGeom prst="rect">
@@ -3234,8 +3234,8 @@
         </p:nvSpPr>
         <p:spPr>
           <a:xfrm>
-            <a:off x="4785360" y="1600200"/>
-            <a:ext cx="1920240" cy="685800"/>
+            <a:off x="3749040" y="1600200"/>
+            <a:ext cx="1645920" cy="685800"/>
           </a:xfrm>
           <a:prstGeom prst="rect">
             <a:avLst/>
@@ -3259,7 +3259,7 @@
                   <a:schemeClr val="tx1"/>
                 </a:solidFill>
               </a:rPr>
-              <a:t>Playable world</a:t>
+              <a:t>Starts where the players are</a:t>
             </a:r>
             <a:endParaRPr lang="en-US" sz="1100" dirty="0"/>
           </a:p>
@@ -3273,7 +3273,7 @@
                   <a:schemeClr val="tx2"/>
                 </a:solidFill>
               </a:rPr>
-              <a:t>two phones join by QR, validated by game code first</a:t>
+              <a:t>the brief builds the spawn zone</a:t>
             </a:r>
             <a:endParaRPr lang="en-US" sz="1100" dirty="0"/>
           </a:p>
@@ -3287,7 +3287,7 @@
         </p:nvSpPr>
         <p:spPr>
           <a:xfrm>
-            <a:off x="7891272" y="1124712"/>
+            <a:off x="6131052" y="1124712"/>
             <a:ext cx="402336" cy="402336"/>
           </a:xfrm>
           <a:prstGeom prst="ellipse">
@@ -3312,7 +3312,7 @@
         </p:nvSpPr>
         <p:spPr>
           <a:xfrm>
-            <a:off x="7891272" y="1124712"/>
+            <a:off x="6131052" y="1124712"/>
             <a:ext cx="402336" cy="402336"/>
           </a:xfrm>
           <a:prstGeom prst="rect">
@@ -3348,8 +3348,8 @@
         </p:nvSpPr>
         <p:spPr>
           <a:xfrm>
-            <a:off x="7132320" y="1600200"/>
-            <a:ext cx="1920240" cy="685800"/>
+            <a:off x="5509260" y="1600200"/>
+            <a:ext cx="1645920" cy="685800"/>
           </a:xfrm>
           <a:prstGeom prst="rect">
             <a:avLst/>
@@ -3373,6 +3373,120 @@
                   <a:schemeClr val="tx1"/>
                 </a:solidFill>
               </a:rPr>
+              <a:t>Grows as they move</a:t>
+            </a:r>
+            <a:endParaRPr lang="en-US" sz="1100" dirty="0"/>
+          </a:p>
+          <a:p>
+            <a:pPr algn="ctr" indent="0" marL="0">
+              <a:buNone/>
+            </a:pPr>
+            <a:r>
+              <a:rPr lang="en-US" sz="900" dirty="0">
+                <a:solidFill>
+                  <a:schemeClr val="tx2"/>
+                </a:solidFill>
+              </a:rPr>
+              <a:t>every extension a small patch, validated before it lands</a:t>
+            </a:r>
+            <a:endParaRPr lang="en-US" sz="1100" dirty="0"/>
+          </a:p>
+        </p:txBody>
+      </p:sp>
+      <p:sp>
+        <p:nvSpPr>
+          <p:cNvPr id="28" name="step circle 5"/>
+          <p:cNvSpPr/>
+          <p:nvPr/>
+        </p:nvSpPr>
+        <p:spPr>
+          <a:xfrm>
+            <a:off x="7891272" y="1124712"/>
+            <a:ext cx="402336" cy="402336"/>
+          </a:xfrm>
+          <a:prstGeom prst="ellipse">
+            <a:avLst/>
+          </a:prstGeom>
+          <a:solidFill>
+            <a:schemeClr val="accent1"/>
+          </a:solidFill>
+          <a:ln w="6350">
+            <a:solidFill>
+              <a:schemeClr val="accent1"/>
+            </a:solidFill>
+            <a:prstDash val="solid"/>
+          </a:ln>
+        </p:spPr>
+      </p:sp>
+      <p:sp>
+        <p:nvSpPr>
+          <p:cNvPr id="29" name="step number 5"/>
+          <p:cNvSpPr txBox="1"/>
+          <p:nvPr/>
+        </p:nvSpPr>
+        <p:spPr>
+          <a:xfrm>
+            <a:off x="7891272" y="1124712"/>
+            <a:ext cx="402336" cy="402336"/>
+          </a:xfrm>
+          <a:prstGeom prst="rect">
+            <a:avLst/>
+          </a:prstGeom>
+          <a:noFill/>
+          <a:ln/>
+        </p:spPr>
+        <p:txBody>
+          <a:bodyPr wrap="square" lIns="0" tIns="0" rIns="0" bIns="0" rtlCol="0" anchor="ctr"/>
+          <a:lstStyle/>
+          <a:p>
+            <a:pPr algn="ctr" indent="0" marL="0">
+              <a:buNone/>
+            </a:pPr>
+            <a:r>
+              <a:rPr lang="en-US" sz="1300" b="1" dirty="0">
+                <a:solidFill>
+                  <a:schemeClr val="bg1"/>
+                </a:solidFill>
+              </a:rPr>
+              <a:t>5</a:t>
+            </a:r>
+            <a:endParaRPr lang="en-US" sz="1300" dirty="0"/>
+          </a:p>
+        </p:txBody>
+      </p:sp>
+      <p:sp>
+        <p:nvSpPr>
+          <p:cNvPr id="30" name="step text 5"/>
+          <p:cNvSpPr txBox="1"/>
+          <p:nvPr/>
+        </p:nvSpPr>
+        <p:spPr>
+          <a:xfrm>
+            <a:off x="7269480" y="1600200"/>
+            <a:ext cx="1645920" cy="685800"/>
+          </a:xfrm>
+          <a:prstGeom prst="rect">
+            <a:avLst/>
+          </a:prstGeom>
+          <a:noFill/>
+          <a:ln/>
+        </p:spPr>
+        <p:txBody>
+          <a:bodyPr wrap="square" lIns="0" tIns="0" rIns="0" bIns="0" rtlCol="0" anchor="t"/>
+          <a:lstStyle/>
+          <a:p>
+            <a:pPr algn="ctr" indent="0" marL="0">
+              <a:spcAft>
+                <a:spcPts val="200"/>
+              </a:spcAft>
+              <a:buNone/>
+            </a:pPr>
+            <a:r>
+              <a:rPr lang="en-US" sz="1100" b="1" dirty="0">
+                <a:solidFill>
+                  <a:schemeClr val="tx1"/>
+                </a:solidFill>
+              </a:rPr>
               <a:t>Keep changing it while they play</a:t>
             </a:r>
             <a:endParaRPr lang="en-US" sz="1100" dirty="0"/>
@@ -3395,13 +3509,13 @@
       </p:sp>
       <p:sp>
         <p:nvSpPr>
-          <p:cNvPr id="28" name="label MODE LIBRARY (ENGINE MECHANICS, NOT MODEL-WRITTEN RULES)"/>
+          <p:cNvPr id="31" name="label MODE LIBRARY (ENGINE MECHANICS, NOT MODEL-WRITTEN RULES)"/>
           <p:cNvSpPr txBox="1"/>
           <p:nvPr/>
         </p:nvSpPr>
         <p:spPr>
           <a:xfrm>
-            <a:off x="457200" y="2286000"/>
+            <a:off x="457200" y="2258568"/>
             <a:ext cx="5943600" cy="182880"/>
           </a:xfrm>
           <a:prstGeom prst="rect">
@@ -3444,7 +3558,7 @@
           </p:nvPr>
         </p:nvGraphicFramePr>
         <p:xfrm>
-          <a:off x="457200" y="2487168"/>
+          <a:off x="457200" y="2432304"/>
           <a:ext cx="8229600" cy="914400"/>
         </p:xfrm>
         <a:graphic>
@@ -5107,14 +5221,14 @@
       </p:graphicFrame>
       <p:sp>
         <p:nvSpPr>
-          <p:cNvPr id="30" name="library text"/>
+          <p:cNvPr id="33" name="library text"/>
           <p:cNvSpPr txBox="1"/>
           <p:nvPr/>
         </p:nvSpPr>
         <p:spPr>
           <a:xfrm>
-            <a:off x="457200" y="3986784"/>
-            <a:ext cx="8229600" cy="365760"/>
+            <a:off x="457200" y="3959352"/>
+            <a:ext cx="8229600" cy="402336"/>
           </a:xfrm>
           <a:prstGeom prst="rect">
             <a:avLst/>
@@ -5168,7 +5282,7 @@
                   <a:schemeClr val="tx1"/>
                 </a:solidFill>
               </a:rPr>
-              <a:t>water or lava below, a rising hazard, movement 3 to 7 m/s, 11 decoration types.   </a:t>
+              <a:t>water or lava, a rising hazard, 3 to 7 m/s, 11 decoration types.   </a:t>
             </a:r>
             <a:pPr indent="0" marL="0">
               <a:buNone/>
@@ -5190,7 +5304,29 @@
                   <a:schemeClr val="tx1"/>
                 </a:solidFill>
               </a:rPr>
-              <a:t>set_mode, set_biome, set_movement beside add_bridge, set_hazard and the other structural ops; every patch validated and committed as a new version.</a:t>
+              <a:t>set_mode, set_biome, set_movement and the structural ops, each validated and committed as a new version.   </a:t>
+            </a:r>
+            <a:pPr indent="0" marL="0">
+              <a:buNone/>
+            </a:pPr>
+            <a:r>
+              <a:rPr lang="en-US" sz="900" b="1" dirty="0">
+                <a:solidFill>
+                  <a:schemeClr val="accent1"/>
+                </a:solidFill>
+              </a:rPr>
+              <a:t>Streaming </a:t>
+            </a:r>
+            <a:pPr indent="0" marL="0">
+              <a:buNone/>
+            </a:pPr>
+            <a:r>
+              <a:rPr lang="en-US" sz="900" dirty="0">
+                <a:solidFill>
+                  <a:schemeClr val="tx1"/>
+                </a:solidFill>
+              </a:rPr>
+              <a:t>extends the world ahead of players near an edge, up to 24 islands and 48 bridges; the director can switch it off.</a:t>
             </a:r>
             <a:endParaRPr lang="en-US" sz="900" dirty="0"/>
           </a:p>
@@ -5198,14 +5334,14 @@
       </p:sp>
       <p:sp>
         <p:nvSpPr>
-          <p:cNvPr id="31" name="category note"/>
+          <p:cNvPr id="34" name="category note"/>
           <p:cNvSpPr txBox="1"/>
           <p:nvPr/>
         </p:nvSpPr>
         <p:spPr>
           <a:xfrm>
-            <a:off x="457200" y="4370832"/>
-            <a:ext cx="8229600" cy="347472"/>
+            <a:off x="457200" y="4425696"/>
+            <a:ext cx="8229600" cy="310896"/>
           </a:xfrm>
           <a:prstGeom prst="rect">
             <a:avLst/>
@@ -5221,14 +5357,14 @@
               <a:buNone/>
             </a:pPr>
             <a:r>
-              <a:rPr lang="en-US" sz="800" i="1" dirty="0">
+              <a:rPr lang="en-US" sz="750" i="1" dirty="0">
                 <a:solidFill>
                   <a:schemeClr val="tx2"/>
                 </a:solidFill>
               </a:rPr>
               <a:t>Adapted from one-prompt game generators: the one-prompt front door and instant playable output. Added: live editing without a reset, deterministic validation and repair before publish, local-only inference, phones as controllers (docs/COMPETITIVE.md). A request outside the library lands on the nearest mode and the agent says so.</a:t>
             </a:r>
-            <a:endParaRPr lang="en-US" sz="800" dirty="0"/>
+            <a:endParaRPr lang="en-US" sz="750" dirty="0"/>
           </a:p>
         </p:txBody>
       </p:sp>
@@ -6470,7 +6606,7 @@
       </p:sp>
       <p:sp>
         <p:nvSpPr>
-          <p:cNvPr id="15" name="node Director"/>
+          <p:cNvPr id="15" name="node Director or frontier"/>
           <p:cNvSpPr/>
           <p:nvPr/>
         </p:nvSpPr>
@@ -6497,7 +6633,7 @@
       </p:sp>
       <p:sp>
         <p:nvSpPr>
-          <p:cNvPr id="16" name="node title Director"/>
+          <p:cNvPr id="16" name="node title Director or frontier"/>
           <p:cNvSpPr txBox="1"/>
           <p:nvPr/>
         </p:nvSpPr>
@@ -6525,7 +6661,7 @@
                   <a:schemeClr val="tx1"/>
                 </a:solidFill>
               </a:rPr>
-              <a:t>Director</a:t>
+              <a:t>Director or frontier</a:t>
             </a:r>
             <a:endParaRPr lang="en-US" sz="1050" dirty="0"/>
           </a:p>
@@ -6533,7 +6669,7 @@
       </p:sp>
       <p:sp>
         <p:nvSpPr>
-          <p:cNvPr id="17" name="node sub Director"/>
+          <p:cNvPr id="17" name="node sub Director or frontier"/>
           <p:cNvSpPr txBox="1"/>
           <p:nvPr/>
         </p:nvSpPr>
@@ -6561,7 +6697,7 @@
                   <a:schemeClr val="tx2"/>
                 </a:solidFill>
               </a:rPr>
-              <a:t>any game request or edit</a:t>
+              <a:t>a request or edit; or a player 4 m from a rim with no crossing beyond</a:t>
             </a:r>
             <a:endParaRPr lang="en-US" sz="850" dirty="0"/>
           </a:p>
@@ -6930,7 +7066,7 @@
                   <a:schemeClr val="tx2"/>
                 </a:solidFill>
               </a:rPr>
-              <a:t>schema-checked JSON only, nothing executed</a:t>
+              <a:t>schema-checked JSON only, nothing executed; add_island for extensions</a:t>
             </a:r>
             <a:endParaRPr lang="en-US" sz="850" dirty="0"/>
           </a:p>
@@ -7290,18 +7426,18 @@
       </p:sp>
       <p:sp>
         <p:nvSpPr>
-          <p:cNvPr id="42" name="state card"/>
+          <p:cNvPr id="42" name="lower card 1"/>
           <p:cNvSpPr/>
           <p:nvPr/>
         </p:nvSpPr>
         <p:spPr>
           <a:xfrm>
             <a:off x="457200" y="3017520"/>
-            <a:ext cx="3977640" cy="1600200"/>
+            <a:ext cx="2651760" cy="1645920"/>
           </a:xfrm>
           <a:prstGeom prst="roundRect">
             <a:avLst>
-              <a:gd name="adj" fmla="val 4571"/>
+              <a:gd name="adj" fmla="val 4444"/>
             </a:avLst>
           </a:prstGeom>
           <a:solidFill>
@@ -7323,8 +7459,8 @@
         </p:nvSpPr>
         <p:spPr>
           <a:xfrm>
-            <a:off x="640080" y="3154680"/>
-            <a:ext cx="3657600" cy="228600"/>
+            <a:off x="594360" y="3127248"/>
+            <a:ext cx="2377440" cy="228600"/>
           </a:xfrm>
           <a:prstGeom prst="rect">
             <a:avLst/>
@@ -7340,27 +7476,27 @@
               <a:buNone/>
             </a:pPr>
             <a:r>
-              <a:rPr lang="en-US" sz="1000" b="1" spc="200" kern="0" dirty="0">
+              <a:rPr lang="en-US" sz="850" b="1" spc="200" kern="0" dirty="0">
                 <a:solidFill>
                   <a:schemeClr val="accent1"/>
                 </a:solidFill>
               </a:rPr>
               <a:t>TWO KINDS OF STATE</a:t>
             </a:r>
-            <a:endParaRPr lang="en-US" sz="1000" dirty="0"/>
-          </a:p>
-        </p:txBody>
-      </p:sp>
-      <p:sp>
-        <p:nvSpPr>
-          <p:cNvPr id="44" name="state bullets"/>
+            <a:endParaRPr lang="en-US" sz="850" dirty="0"/>
+          </a:p>
+        </p:txBody>
+      </p:sp>
+      <p:sp>
+        <p:nvSpPr>
+          <p:cNvPr id="44" name="lower card bullets 1"/>
           <p:cNvSpPr txBox="1"/>
           <p:nvPr/>
         </p:nvSpPr>
         <p:spPr>
           <a:xfrm>
-            <a:off x="640080" y="3401568"/>
-            <a:ext cx="3657600" cy="1143000"/>
+            <a:off x="594360" y="3364992"/>
+            <a:ext cx="2377440" cy="1234440"/>
           </a:xfrm>
           <a:prstGeom prst="rect">
             <a:avLst/>
@@ -7380,14 +7516,14 @@
               <a:buChar char="•"/>
             </a:pPr>
             <a:r>
-              <a:rPr lang="en-US" sz="1050" dirty="0">
+              <a:rPr lang="en-US" sz="850" dirty="0">
                 <a:solidFill>
                   <a:schemeClr val="tx1"/>
                 </a:solidFill>
               </a:rPr>
-              <a:t>WorldSpec is structure, now with mode, biome, movement and hazard.rise. It changes only when a transaction commits, one version per commit.</a:t>
-            </a:r>
-            <a:endParaRPr lang="en-US" sz="1050" dirty="0"/>
+              <a:t>WorldSpec is structure: islands, bridges, mode, biome, movement, hazard. One version per committed transaction.</a:t>
+            </a:r>
+            <a:endParaRPr lang="en-US" sz="850" dirty="0"/>
           </a:p>
           <a:p>
             <a:pPr marL="152400" indent="-152400">
@@ -7398,14 +7534,14 @@
               <a:buChar char="•"/>
             </a:pPr>
             <a:r>
-              <a:rPr lang="en-US" sz="1050" dirty="0">
+              <a:rPr lang="en-US" sz="850" dirty="0">
                 <a:solidFill>
                   <a:schemeClr val="tx1"/>
                 </a:solidFill>
               </a:rPr>
-              <a:t>SessionState is players, relics, score and the mode objective (timer, hold time, next checkpoint, hazard height). The simulation advances it; the agent never writes it.</a:t>
-            </a:r>
-            <a:endParaRPr lang="en-US" sz="1050" dirty="0"/>
+              <a:t>SessionState is players, relics, score and the mode objective. The simulation advances it; the agent never writes it.</a:t>
+            </a:r>
+            <a:endParaRPr lang="en-US" sz="850" dirty="0"/>
           </a:p>
           <a:p>
             <a:pPr marL="152400" indent="-152400">
@@ -7416,31 +7552,31 @@
               <a:buChar char="•"/>
             </a:pPr>
             <a:r>
-              <a:rPr lang="en-US" sz="1050" dirty="0">
+              <a:rPr lang="en-US" sz="850" dirty="0">
                 <a:solidFill>
                   <a:schemeClr val="tx1"/>
                 </a:solidFill>
               </a:rPr>
               <a:t>Commit needs a server-issued proof.</a:t>
             </a:r>
-            <a:endParaRPr lang="en-US" sz="1050" dirty="0"/>
-          </a:p>
-        </p:txBody>
-      </p:sp>
-      <p:sp>
-        <p:nvSpPr>
-          <p:cNvPr id="45" name="validation card"/>
-          <p:cNvSpPr/>
-          <p:nvPr/>
-        </p:nvSpPr>
-        <p:spPr>
-          <a:xfrm>
-            <a:off x="4709160" y="3017520"/>
-            <a:ext cx="3977640" cy="1600200"/>
+            <a:endParaRPr lang="en-US" sz="850" dirty="0"/>
+          </a:p>
+        </p:txBody>
+      </p:sp>
+      <p:sp>
+        <p:nvSpPr>
+          <p:cNvPr id="45" name="lower card 2"/>
+          <p:cNvSpPr/>
+          <p:nvPr/>
+        </p:nvSpPr>
+        <p:spPr>
+          <a:xfrm>
+            <a:off x="3246120" y="3017520"/>
+            <a:ext cx="2651760" cy="1645920"/>
           </a:xfrm>
           <a:prstGeom prst="roundRect">
             <a:avLst>
-              <a:gd name="adj" fmla="val 4571"/>
+              <a:gd name="adj" fmla="val 4444"/>
             </a:avLst>
           </a:prstGeom>
           <a:solidFill>
@@ -7462,8 +7598,8 @@
         </p:nvSpPr>
         <p:spPr>
           <a:xfrm>
-            <a:off x="4892040" y="3154680"/>
-            <a:ext cx="3657600" cy="228600"/>
+            <a:off x="3383280" y="3127248"/>
+            <a:ext cx="2377440" cy="228600"/>
           </a:xfrm>
           <a:prstGeom prst="rect">
             <a:avLst/>
@@ -7479,27 +7615,27 @@
               <a:buNone/>
             </a:pPr>
             <a:r>
-              <a:rPr lang="en-US" sz="1000" b="1" spc="200" kern="0" dirty="0">
+              <a:rPr lang="en-US" sz="850" b="1" spc="200" kern="0" dirty="0">
                 <a:solidFill>
                   <a:schemeClr val="accent1"/>
                 </a:solidFill>
               </a:rPr>
               <a:t>VALIDATION IS GAME CODE</a:t>
             </a:r>
-            <a:endParaRPr lang="en-US" sz="1000" dirty="0"/>
-          </a:p>
-        </p:txBody>
-      </p:sp>
-      <p:sp>
-        <p:nvSpPr>
-          <p:cNvPr id="47" name="validation bullets"/>
+            <a:endParaRPr lang="en-US" sz="850" dirty="0"/>
+          </a:p>
+        </p:txBody>
+      </p:sp>
+      <p:sp>
+        <p:nvSpPr>
+          <p:cNvPr id="47" name="lower card bullets 2"/>
           <p:cNvSpPr txBox="1"/>
           <p:nvPr/>
         </p:nvSpPr>
         <p:spPr>
           <a:xfrm>
-            <a:off x="4892040" y="3401568"/>
-            <a:ext cx="3657600" cy="1143000"/>
+            <a:off x="3383280" y="3364992"/>
+            <a:ext cx="2377440" cy="1234440"/>
           </a:xfrm>
           <a:prstGeom prst="rect">
             <a:avLst/>
@@ -7519,14 +7655,14 @@
               <a:buChar char="•"/>
             </a:pPr>
             <a:r>
-              <a:rPr lang="en-US" sz="1050" dirty="0">
+              <a:rPr lang="en-US" sz="850" dirty="0">
                 <a:solidFill>
                   <a:schemeClr val="tx1"/>
                 </a:solidFill>
               </a:rPr>
               <a:t>Geometry, bridge sockets, walk field, reachability with the gate locked, occupied support at commit time.</a:t>
             </a:r>
-            <a:endParaRPr lang="en-US" sz="1050" dirty="0"/>
+            <a:endParaRPr lang="en-US" sz="850" dirty="0"/>
           </a:p>
           <a:p>
             <a:pPr marL="152400" indent="-152400">
@@ -7537,14 +7673,14 @@
               <a:buChar char="•"/>
             </a:pPr>
             <a:r>
-              <a:rPr lang="en-US" sz="1050" dirty="0">
+              <a:rPr lang="en-US" sz="850" dirty="0">
                 <a:solidFill>
                   <a:schemeClr val="tx1"/>
                 </a:solidFill>
               </a:rPr>
               <a:t>MODE_INVALID: relics required above the count, a race with under 2 checkpoints, survival without a rising hazard, a timer outside 20 to 600 s.</a:t>
             </a:r>
-            <a:endParaRPr lang="en-US" sz="1050" dirty="0"/>
+            <a:endParaRPr lang="en-US" sz="850" dirty="0"/>
           </a:p>
           <a:p>
             <a:pPr marL="152400" indent="-152400">
@@ -7555,14 +7691,153 @@
               <a:buChar char="•"/>
             </a:pPr>
             <a:r>
-              <a:rPr lang="en-US" sz="1050" dirty="0">
+              <a:rPr lang="en-US" sz="850" dirty="0">
                 <a:solidFill>
                   <a:schemeClr val="tx1"/>
                 </a:solidFill>
               </a:rPr>
-              <a:t>The mode rule is engine code picked by an enum. An LLM saying valid is never approval. Output is schema-checked JSON only.</a:t>
-            </a:r>
-            <a:endParaRPr lang="en-US" sz="1050" dirty="0"/>
+              <a:t>An LLM saying valid is never approval.</a:t>
+            </a:r>
+            <a:endParaRPr lang="en-US" sz="850" dirty="0"/>
+          </a:p>
+        </p:txBody>
+      </p:sp>
+      <p:sp>
+        <p:nvSpPr>
+          <p:cNvPr id="48" name="lower card 3"/>
+          <p:cNvSpPr/>
+          <p:nvPr/>
+        </p:nvSpPr>
+        <p:spPr>
+          <a:xfrm>
+            <a:off x="6035040" y="3017520"/>
+            <a:ext cx="2651760" cy="1645920"/>
+          </a:xfrm>
+          <a:prstGeom prst="roundRect">
+            <a:avLst>
+              <a:gd name="adj" fmla="val 4444"/>
+            </a:avLst>
+          </a:prstGeom>
+          <a:solidFill>
+            <a:schemeClr val="bg2"/>
+          </a:solidFill>
+          <a:ln w="9525">
+            <a:solidFill>
+              <a:schemeClr val="accent4"/>
+            </a:solidFill>
+            <a:prstDash val="solid"/>
+          </a:ln>
+        </p:spPr>
+      </p:sp>
+      <p:sp>
+        <p:nvSpPr>
+          <p:cNvPr id="49" name="label GROWS AHEAD OF PLAYERS"/>
+          <p:cNvSpPr txBox="1"/>
+          <p:nvPr/>
+        </p:nvSpPr>
+        <p:spPr>
+          <a:xfrm>
+            <a:off x="6172200" y="3127248"/>
+            <a:ext cx="2377440" cy="228600"/>
+          </a:xfrm>
+          <a:prstGeom prst="rect">
+            <a:avLst/>
+          </a:prstGeom>
+          <a:noFill/>
+          <a:ln/>
+        </p:spPr>
+        <p:txBody>
+          <a:bodyPr wrap="square" lIns="0" tIns="0" rIns="0" bIns="0" rtlCol="0" anchor="ctr"/>
+          <a:lstStyle/>
+          <a:p>
+            <a:pPr indent="0" marL="0">
+              <a:buNone/>
+            </a:pPr>
+            <a:r>
+              <a:rPr lang="en-US" sz="850" b="1" spc="200" kern="0" dirty="0">
+                <a:solidFill>
+                  <a:schemeClr val="accent1"/>
+                </a:solidFill>
+              </a:rPr>
+              <a:t>GROWS AHEAD OF PLAYERS</a:t>
+            </a:r>
+            <a:endParaRPr lang="en-US" sz="850" dirty="0"/>
+          </a:p>
+        </p:txBody>
+      </p:sp>
+      <p:sp>
+        <p:nvSpPr>
+          <p:cNvPr id="50" name="lower card bullets 3"/>
+          <p:cNvSpPr txBox="1"/>
+          <p:nvPr/>
+        </p:nvSpPr>
+        <p:spPr>
+          <a:xfrm>
+            <a:off x="6172200" y="3364992"/>
+            <a:ext cx="2377440" cy="1234440"/>
+          </a:xfrm>
+          <a:prstGeom prst="rect">
+            <a:avLst/>
+          </a:prstGeom>
+          <a:noFill/>
+          <a:ln/>
+        </p:spPr>
+        <p:txBody>
+          <a:bodyPr wrap="square" lIns="0" tIns="0" rIns="0" bIns="0" rtlCol="0" anchor="t"/>
+          <a:lstStyle/>
+          <a:p>
+            <a:pPr marL="152400" indent="-152400">
+              <a:spcAft>
+                <a:spcPts val="500"/>
+              </a:spcAft>
+              <a:buSzPct val="100000"/>
+              <a:buChar char="•"/>
+            </a:pPr>
+            <a:r>
+              <a:rPr lang="en-US" sz="850" dirty="0">
+                <a:solidFill>
+                  <a:schemeClr val="tx1"/>
+                </a:solidFill>
+              </a:rPr>
+              <a:t>Frontier trigger: a player within 4 m of a rim with no crossing beyond; at least 12 s between extensions.</a:t>
+            </a:r>
+            <a:endParaRPr lang="en-US" sz="850" dirty="0"/>
+          </a:p>
+          <a:p>
+            <a:pPr marL="152400" indent="-152400">
+              <a:spcAft>
+                <a:spcPts val="500"/>
+              </a:spcAft>
+              <a:buSzPct val="100000"/>
+              <a:buChar char="•"/>
+            </a:pPr>
+            <a:r>
+              <a:rPr lang="en-US" sz="850" dirty="0">
+                <a:solidFill>
+                  <a:schemeClr val="tx1"/>
+                </a:solidFill>
+              </a:rPr>
+              <a:t>Beetle opens the request itself (marked auto); the agent answers with add_island, 1 to 2 islands, each bridged from an anchor.</a:t>
+            </a:r>
+            <a:endParaRPr lang="en-US" sz="850" dirty="0"/>
+          </a:p>
+          <a:p>
+            <a:pPr marL="152400" indent="-152400">
+              <a:spcAft>
+                <a:spcPts val="500"/>
+              </a:spcAft>
+              <a:buSzPct val="100000"/>
+              <a:buChar char="•"/>
+            </a:pPr>
+            <a:r>
+              <a:rPr lang="en-US" sz="850" dirty="0">
+                <a:solidFill>
+                  <a:schemeClr val="tx1"/>
+                </a:solidFill>
+              </a:rPr>
+              <a:t>Same validator and commit. Stops at 24 islands, 48 bridges; director toggle.</a:t>
+            </a:r>
+            <a:endParaRPr lang="en-US" sz="850" dirty="0"/>
           </a:p>
         </p:txBody>
       </p:sp>
@@ -9275,7 +9550,7 @@
                   <a:schemeClr val="accent1"/>
                 </a:solidFill>
               </a:rPr>
-              <a:t>0.48 ms RTT, 18.8 ms tick</a:t>
+              <a:t>0.56 ms RTT, 0.80 ms tick</a:t>
             </a:r>
             <a:endParaRPr lang="en-US" sz="1100" dirty="0"/>
           </a:p>
@@ -9311,7 +9586,7 @@
                   <a:schemeClr val="tx2"/>
                 </a:solidFill>
               </a:rPr>
-              <a:t>p50, scripted controllers (p95 0.81 and 33.1 ms; LATENCY.md). Not input to photon: no phone, Wi-Fi, browser or display.</a:t>
+              <a:t>p50 idle, scripted controllers (p95 1.01 and 1.10 ms; under 2 x 30 inputs/s tick p95 50.2 ms; LATENCY.md 20:10Z). Not input to photon.</a:t>
             </a:r>
             <a:endParaRPr lang="en-US" sz="680" dirty="0"/>
           </a:p>
@@ -9589,14 +9864,14 @@
       </p:sp>
       <p:sp>
         <p:nvSpPr>
-          <p:cNvPr id="63" name="sources note"/>
+          <p:cNvPr id="63" name="streaming status"/>
           <p:cNvSpPr txBox="1"/>
           <p:nvPr/>
         </p:nvSpPr>
         <p:spPr>
           <a:xfrm>
-            <a:off x="457200" y="4261104"/>
-            <a:ext cx="8229600" cy="420624"/>
+            <a:off x="457200" y="4206240"/>
+            <a:ext cx="8229600" cy="274320"/>
           </a:xfrm>
           <a:prstGeom prst="rect">
             <a:avLst/>
@@ -9612,14 +9887,50 @@
               <a:buNone/>
             </a:pPr>
             <a:r>
-              <a:rPr lang="en-US" sz="800" i="1" dirty="0">
+              <a:rPr lang="en-US" sz="800" b="1" dirty="0">
+                <a:solidFill>
+                  <a:schemeClr val="accent1"/>
+                </a:solidFill>
+              </a:rPr>
+              <a:t>Streaming generation: implemented. One live run: extension committed 9.5 s after the frontier trigger, player preserved (RESULTS.md 15:16 CDT, direct, quiet GPU). Acceptance numbers to follow.</a:t>
+            </a:r>
+            <a:endParaRPr lang="en-US" sz="800" dirty="0"/>
+          </a:p>
+        </p:txBody>
+      </p:sp>
+      <p:sp>
+        <p:nvSpPr>
+          <p:cNvPr id="64" name="sources note"/>
+          <p:cNvSpPr txBox="1"/>
+          <p:nvPr/>
+        </p:nvSpPr>
+        <p:spPr>
+          <a:xfrm>
+            <a:off x="457200" y="4498848"/>
+            <a:ext cx="8229600" cy="237744"/>
+          </a:xfrm>
+          <a:prstGeom prst="rect">
+            <a:avLst/>
+          </a:prstGeom>
+          <a:noFill/>
+          <a:ln/>
+        </p:spPr>
+        <p:txBody>
+          <a:bodyPr wrap="square" lIns="0" tIns="0" rIns="0" bIns="0" rtlCol="0" anchor="ctr"/>
+          <a:lstStyle/>
+          <a:p>
+            <a:pPr indent="0" marL="0">
+              <a:buNone/>
+            </a:pPr>
+            <a:r>
+              <a:rPr lang="en-US" sz="700" i="1" dirty="0">
                 <a:solidFill>
                   <a:schemeClr val="tx2"/>
                 </a:solidFill>
               </a:rPr>
               <a:t>Direct-harness timings are labelled [direct] in every report; OpenClaw timings are from the real server after the Ollama daemon restart at 13:43 CDT. Each card names its GPU state because the daemon was shared for most of the day. Mode briefs were measured at 14:25 to 14:42 CDT in direct mode with no controllers connected (docs/RESULTS.md).</a:t>
             </a:r>
-            <a:endParaRPr lang="en-US" sz="800" dirty="0"/>
+            <a:endParaRPr lang="en-US" sz="700" dirty="0"/>
           </a:p>
         </p:txBody>
       </p:sp>

</xml_diff>

<commit_message>
Pitch: measured streaming extensions, latency 0.78 ms p50, deck rebuilt
</commit_message>
<xml_diff>
--- a/docs/pitch/Beetle-pitch.pptx
+++ b/docs/pitch/Beetle-pitch.pptx
@@ -112,7 +112,7 @@
   <p:extLst>
     <p:ext uri="{521415D9-36F7-43E2-AB2F-B90AF26B5E84}">
       <p14:sectionLst xmlns:p14="http://schemas.microsoft.com/office/powerpoint/2010/main">
-        <p14:section name="Beetle pitch" id="{7efa93a3-c713-133a-0a0f-69940126bcf4}">
+        <p14:section name="Beetle pitch" id="{1a24690c-802f-7b5c-bc4e-7519a5cbf1b5}">
           <p14:sldIdLst>
             <p14:sldId id="256"/>
             <p14:sldId id="257"/>
@@ -614,7 +614,7 @@
           <a:p>
             <a:r>
               <a:rPr lang="en-US" dirty="0"/>
-              <a:t>Walk the five steps: any request, mapped to the closest mode and biome and named; the world starts where the players are (the brief builds the zone around the spawn); it grows as they move, every extension a small patch validated before it lands; then keep changing it while they play. Read two rows of the mode table, not all five. Say plainly: the library is bounded and growing; the model never writes rules, it picks from the engine. Streaming was measured once: an automatic extension (two islands) committed 9.5 s after the frontier trigger with the player preserved (docs/RESULTS.md 15:16 CDT, direct, quiet GPU). Say 'measured once'; the spawn-zone brief time is not measured. Mode briefs measured 14:25 to 14:42 CDT, 18 of 18 sensible modes (slide 5).</a:t>
+              <a:t>Walk the five steps: any request, mapped to the closest mode and biome and named; the world starts where the players are (the brief builds the zone around the spawn); it grows as they move, every extension a small patch validated before it lands; then keep changing it while they play. Read two rows of the mode table, not all five. Say plainly: the library is bounded and growing; the model never writes rules, it picks from the engine. Streaming is measured: in the acceptance runs (contended GPU) 4 of 6 automatic extensions committed in 10.6 to 65.9 s, and one quiet-GPU run committed in 9.5 s (slide 5). The spawn-zone brief time is not measured. Mode briefs measured 14:25 to 14:42 CDT, 18 of 18 sensible modes (slide 5).</a:t>
             </a:r>
             <a:endParaRPr lang="en-US" dirty="0"/>
           </a:p>
@@ -702,7 +702,7 @@
           <a:p>
             <a:r>
               <a:rPr lang="en-US" dirty="0"/>
-              <a:t>Play the recording here. Captions follow docs/STORYBOARD.md; the mode caption is set to whichever agent mode was green at recording time. Rehearsal timings: brief 14 s on a quiet GPU, edits 2 to 14 s, DISCONNECTED_GOAL refused and repaired in 3.0 s. Shots that cannot be produced honestly are cut, not faked. Optional shot 'the world grows' (docs/STORYBOARD.md 6c): a player walks toward an edge, 'Beetle is building ahead' appears and the new island assembles; one live run committed an extension 9.5 s after the trigger (docs/RESULTS.md 15:16 CDT), not yet rehearsed on camera, so it is shown only from a real take, never compressed without a label.</a:t>
+              <a:t>Play the recording here. Captions follow docs/STORYBOARD.md; the mode caption is set to whichever agent mode was green at recording time. Rehearsal timings: brief 14 s on a quiet GPU, edits 2 to 14 s, DISCONNECTED_GOAL refused and repaired in 3.0 s. Shots that cannot be produced honestly are cut, not faked. Optional shot 'the world grows' (docs/STORYBOARD.md 6c): a player walks toward an edge, 'Beetle is building ahead' appears and the new island assembles; measured 10.6 to 65.9 s request to commit on a contended GPU (docs/ACCEPTANCE.md) and 9.5 s once on a quiet GPU (docs/RESULTS.md), not yet rehearsed on camera, so it is shown only from a real take, never compressed without a label.</a:t>
             </a:r>
             <a:endParaRPr lang="en-US" dirty="0"/>
           </a:p>
@@ -878,7 +878,7 @@
           <a:p>
             <a:r>
               <a:rPr lang="en-US" dirty="0"/>
-              <a:t>Read the cards. Say out loud: the 10 s brief target is not met; a valid brief takes 24 to 28 s warm on a quiet GPU, 14 s was seen once after normalization, 33.4 s through OpenClaw. Edits commit in 2 to 14 s, and 8.0 s with two players moving and nothing reset. Game modes from one prompt: the mode was sensible on 18 of 18 briefs and the exact mode was missed twice; committed mode briefs took 13 to 44 s and the failures were geometry, never the mode rule; mode and biome edits on a running world took 3.0 s. Phones and the offline proof are covered by tests or procedure but not yet measured live. Streaming generation is implemented and was measured once live: extension committed 9.5 s after the frontier trigger, player preserved (docs/RESULTS.md 15:16 CDT); say 'one run, acceptance numbers to follow'. No spawn-zone build time is quoted. The 27b was never benchmarked.</a:t>
+              <a:t>Read the cards. Say out loud: the 10 s brief target is not met; a valid brief takes 24 to 28 s warm on a quiet GPU, 14 s was seen once after normalization, 33.4 s through OpenClaw. Edits commit in 2 to 14 s, and 8.0 s with two players moving and nothing reset. Game modes from one prompt: the mode was sensible on 18 of 18 briefs and the exact mode was missed twice; committed mode briefs took 13 to 44 s and the failures were geometry, never the mode rule; mode and biome edits on a running world took 3.0 s. Phones and the offline proof are covered by tests or procedure but not yet measured live. Streaming: the frontier trigger opens the request within 0.3 s; the model is the slow part. Acceptance runs on a contended GPU: 4 of 6 extensions committed in 10.6 to 65.9 s, one failed schema validation, one hit the 80 s model timeout, and each failure left the world untouched; run 3 passed 21 of 21 with player, relic and score kept and the player walking onto both new islands. Quiet GPU, once: 9.5 s. No spawn-zone build time is quoted. The 27b was never benchmarked.</a:t>
             </a:r>
             <a:endParaRPr lang="en-US" dirty="0"/>
           </a:p>
@@ -9550,7 +9550,7 @@
                   <a:schemeClr val="accent1"/>
                 </a:solidFill>
               </a:rPr>
-              <a:t>0.56 ms RTT, 0.80 ms tick</a:t>
+              <a:t>0.46 ms RTT, 0.78 ms tick</a:t>
             </a:r>
             <a:endParaRPr lang="en-US" sz="1100" dirty="0"/>
           </a:p>
@@ -9586,7 +9586,7 @@
                   <a:schemeClr val="tx2"/>
                 </a:solidFill>
               </a:rPr>
-              <a:t>p50 idle, scripted controllers (p95 1.01 and 1.10 ms; under 2 x 30 inputs/s tick p95 50.2 ms; LATENCY.md 20:10Z). Not input to photon.</a:t>
+              <a:t>p50 idle, scripted controllers (p95 0.74 and 1.15 ms; under 2 x 30 inputs/s tick p95 12.3 ms; LATENCY.md 20:26Z). Not input to photon.</a:t>
             </a:r>
             <a:endParaRPr lang="en-US" sz="680" dirty="0"/>
           </a:p>
@@ -9892,7 +9892,7 @@
                   <a:schemeClr val="accent1"/>
                 </a:solidFill>
               </a:rPr>
-              <a:t>Streaming generation: implemented. One live run: extension committed 9.5 s after the frontier trigger, player preserved (RESULTS.md 15:16 CDT, direct, quiet GPU). Acceptance numbers to follow.</a:t>
+              <a:t>Streaming, extension request to commit: 10.6 to 65.9 s, 4 of 6 committed, GPU contended (ACCEPTANCE.md, run 3 PASS 21 of 21: 56.0 s and 10.6 s); 9.5 s once on a quiet GPU (RESULTS.md). Trigger to request under 0.3 s; player, relic and score kept.</a:t>
             </a:r>
             <a:endParaRPr lang="en-US" sz="800" dirty="0"/>
           </a:p>

</xml_diff>